<commit_message>
docs: add methods appendix to the slide deck (6 technical backup slides)
Data prep, outlier method, network construction, cost-driver model + CV/eta2
tables, falsification + cost x quality, robustness/limitations. Read-ahead
deck refreshed; presenting (with-notes) version stays local.

Co-Authored-By: Claude Opus 4.8 <noreply@anthropic.com>
</commit_message>
<xml_diff>
--- a/docs/slides/UHC_Affordability_Deck_readahead.pptx
+++ b/docs/slides/UHC_Affordability_Deck_readahead.pptx
@@ -19,6 +19,13 @@
     <p:sldId id="267" r:id="rId18"/>
     <p:sldId id="268" r:id="rId19"/>
     <p:sldId id="269" r:id="rId20"/>
+    <p:sldId id="270" r:id="rId21"/>
+    <p:sldId id="271" r:id="rId22"/>
+    <p:sldId id="272" r:id="rId23"/>
+    <p:sldId id="273" r:id="rId24"/>
+    <p:sldId id="274" r:id="rId25"/>
+    <p:sldId id="275" r:id="rId26"/>
+    <p:sldId id="276" r:id="rId27"/>
   </p:sldIdLst>
   <p:sldSz cx="12191695" cy="6858000" type="screen4x3"/>
   <p:notesSz cx="6858000" cy="9144000"/>
@@ -5642,6 +5649,2332 @@
 </p:sld>
 </file>
 
+<file path=ppt/slides/slide15.xml><?xml version="1.0" encoding="utf-8"?>
+<p:sld xmlns:a="http://schemas.openxmlformats.org/drawingml/2006/main" xmlns:p="http://schemas.openxmlformats.org/presentationml/2006/main" xmlns:r="http://schemas.openxmlformats.org/officeDocument/2006/relationships">
+  <p:cSld>
+    <p:bg>
+      <p:bgPr>
+        <a:solidFill>
+          <a:srgbClr val="FAF8F2"/>
+        </a:solidFill>
+        <a:effectLst/>
+      </p:bgPr>
+    </p:bg>
+    <p:spTree>
+      <p:nvGrpSpPr>
+        <p:cNvPr id="1" name=""/>
+        <p:cNvGrpSpPr/>
+        <p:nvPr/>
+      </p:nvGrpSpPr>
+      <p:grpSpPr/>
+      <p:sp>
+        <p:nvSpPr>
+          <p:cNvPr id="2" name="Rectangle 1"/>
+          <p:cNvSpPr/>
+          <p:nvPr/>
+        </p:nvSpPr>
+        <p:spPr>
+          <a:xfrm>
+            <a:off x="548640" y="502920"/>
+            <a:ext cx="457200" cy="109728"/>
+          </a:xfrm>
+          <a:prstGeom prst="rect">
+            <a:avLst/>
+          </a:prstGeom>
+          <a:solidFill>
+            <a:srgbClr val="FF612B"/>
+          </a:solidFill>
+          <a:ln>
+            <a:noFill/>
+          </a:ln>
+        </p:spPr>
+        <p:style>
+          <a:lnRef idx="1">
+            <a:schemeClr val="accent1"/>
+          </a:lnRef>
+          <a:fillRef idx="3">
+            <a:schemeClr val="accent1"/>
+          </a:fillRef>
+          <a:effectRef idx="2">
+            <a:schemeClr val="accent1"/>
+          </a:effectRef>
+          <a:fontRef idx="minor">
+            <a:schemeClr val="lt1"/>
+          </a:fontRef>
+        </p:style>
+        <p:txBody>
+          <a:bodyPr rtlCol="0" anchor="ctr"/>
+          <a:lstStyle/>
+          <a:p>
+            <a:pPr algn="ctr"/>
+          </a:p>
+        </p:txBody>
+      </p:sp>
+      <p:sp>
+        <p:nvSpPr>
+          <p:cNvPr id="3" name="TextBox 2"/>
+          <p:cNvSpPr txBox="1"/>
+          <p:nvPr/>
+        </p:nvSpPr>
+        <p:spPr>
+          <a:xfrm>
+            <a:off x="1097280" y="384048"/>
+            <a:ext cx="10515600" cy="365760"/>
+          </a:xfrm>
+          <a:prstGeom prst="rect">
+            <a:avLst/>
+          </a:prstGeom>
+          <a:noFill/>
+        </p:spPr>
+        <p:txBody>
+          <a:bodyPr wrap="square">
+            <a:spAutoFit/>
+          </a:bodyPr>
+          <a:lstStyle/>
+          <a:p>
+            <a:pPr algn="l">
+              <a:spcAft>
+                <a:spcPts val="600"/>
+              </a:spcAft>
+            </a:pPr>
+            <a:r>
+              <a:rPr sz="1300" b="1">
+                <a:solidFill>
+                  <a:srgbClr val="3D3C38"/>
+                </a:solidFill>
+                <a:latin typeface="Arial"/>
+              </a:rPr>
+              <a:t>APPENDIX</a:t>
+            </a:r>
+          </a:p>
+        </p:txBody>
+      </p:sp>
+      <p:sp>
+        <p:nvSpPr>
+          <p:cNvPr id="4" name="TextBox 3"/>
+          <p:cNvSpPr txBox="1"/>
+          <p:nvPr/>
+        </p:nvSpPr>
+        <p:spPr>
+          <a:xfrm>
+            <a:off x="731520" y="2651760"/>
+            <a:ext cx="10515600" cy="1188720"/>
+          </a:xfrm>
+          <a:prstGeom prst="rect">
+            <a:avLst/>
+          </a:prstGeom>
+          <a:noFill/>
+        </p:spPr>
+        <p:txBody>
+          <a:bodyPr wrap="square">
+            <a:spAutoFit/>
+          </a:bodyPr>
+          <a:lstStyle/>
+          <a:p>
+            <a:pPr algn="l">
+              <a:spcAft>
+                <a:spcPts val="600"/>
+              </a:spcAft>
+            </a:pPr>
+            <a:r>
+              <a:rPr sz="3400" b="1">
+                <a:solidFill>
+                  <a:srgbClr val="3D3C38"/>
+                </a:solidFill>
+                <a:latin typeface="Arial"/>
+              </a:rPr>
+              <a:t>Appendix — methods &amp; detail</a:t>
+            </a:r>
+          </a:p>
+        </p:txBody>
+      </p:sp>
+      <p:sp>
+        <p:nvSpPr>
+          <p:cNvPr id="5" name="Rectangle 4"/>
+          <p:cNvSpPr/>
+          <p:nvPr/>
+        </p:nvSpPr>
+        <p:spPr>
+          <a:xfrm>
+            <a:off x="731520" y="3794760"/>
+            <a:ext cx="2743200" cy="91440"/>
+          </a:xfrm>
+          <a:prstGeom prst="rect">
+            <a:avLst/>
+          </a:prstGeom>
+          <a:solidFill>
+            <a:srgbClr val="FF612B"/>
+          </a:solidFill>
+          <a:ln>
+            <a:noFill/>
+          </a:ln>
+        </p:spPr>
+        <p:style>
+          <a:lnRef idx="1">
+            <a:schemeClr val="accent1"/>
+          </a:lnRef>
+          <a:fillRef idx="3">
+            <a:schemeClr val="accent1"/>
+          </a:fillRef>
+          <a:effectRef idx="2">
+            <a:schemeClr val="accent1"/>
+          </a:effectRef>
+          <a:fontRef idx="minor">
+            <a:schemeClr val="lt1"/>
+          </a:fontRef>
+        </p:style>
+        <p:txBody>
+          <a:bodyPr rtlCol="0" anchor="ctr"/>
+          <a:lstStyle/>
+          <a:p>
+            <a:pPr algn="ctr"/>
+          </a:p>
+        </p:txBody>
+      </p:sp>
+      <p:sp>
+        <p:nvSpPr>
+          <p:cNvPr id="6" name="TextBox 5"/>
+          <p:cNvSpPr txBox="1"/>
+          <p:nvPr/>
+        </p:nvSpPr>
+        <p:spPr>
+          <a:xfrm>
+            <a:off x="731520" y="4023360"/>
+            <a:ext cx="10515600" cy="548640"/>
+          </a:xfrm>
+          <a:prstGeom prst="rect">
+            <a:avLst/>
+          </a:prstGeom>
+          <a:noFill/>
+        </p:spPr>
+        <p:txBody>
+          <a:bodyPr wrap="square">
+            <a:spAutoFit/>
+          </a:bodyPr>
+          <a:lstStyle/>
+          <a:p>
+            <a:pPr algn="l">
+              <a:spcAft>
+                <a:spcPts val="600"/>
+              </a:spcAft>
+            </a:pPr>
+            <a:r>
+              <a:rPr sz="1400" b="0">
+                <a:solidFill>
+                  <a:srgbClr val="3D3C38"/>
+                </a:solidFill>
+                <a:latin typeface="Arial"/>
+              </a:rPr>
+              <a:t>Technical backup — the same detail is also in the live dashboard's methods appendix.</a:t>
+            </a:r>
+          </a:p>
+        </p:txBody>
+      </p:sp>
+    </p:spTree>
+  </p:cSld>
+  <p:clrMapOvr>
+    <a:masterClrMapping/>
+  </p:clrMapOvr>
+</p:sld>
+</file>
+
+<file path=ppt/slides/slide16.xml><?xml version="1.0" encoding="utf-8"?>
+<p:sld xmlns:a="http://schemas.openxmlformats.org/drawingml/2006/main" xmlns:p="http://schemas.openxmlformats.org/presentationml/2006/main" xmlns:r="http://schemas.openxmlformats.org/officeDocument/2006/relationships">
+  <p:cSld>
+    <p:bg>
+      <p:bgPr>
+        <a:solidFill>
+          <a:srgbClr val="FAF8F2"/>
+        </a:solidFill>
+        <a:effectLst/>
+      </p:bgPr>
+    </p:bg>
+    <p:spTree>
+      <p:nvGrpSpPr>
+        <p:cNvPr id="1" name=""/>
+        <p:cNvGrpSpPr/>
+        <p:nvPr/>
+      </p:nvGrpSpPr>
+      <p:grpSpPr/>
+      <p:sp>
+        <p:nvSpPr>
+          <p:cNvPr id="2" name="Rectangle 1"/>
+          <p:cNvSpPr/>
+          <p:nvPr/>
+        </p:nvSpPr>
+        <p:spPr>
+          <a:xfrm>
+            <a:off x="548640" y="502920"/>
+            <a:ext cx="457200" cy="109728"/>
+          </a:xfrm>
+          <a:prstGeom prst="rect">
+            <a:avLst/>
+          </a:prstGeom>
+          <a:solidFill>
+            <a:srgbClr val="FF612B"/>
+          </a:solidFill>
+          <a:ln>
+            <a:noFill/>
+          </a:ln>
+        </p:spPr>
+        <p:style>
+          <a:lnRef idx="1">
+            <a:schemeClr val="accent1"/>
+          </a:lnRef>
+          <a:fillRef idx="3">
+            <a:schemeClr val="accent1"/>
+          </a:fillRef>
+          <a:effectRef idx="2">
+            <a:schemeClr val="accent1"/>
+          </a:effectRef>
+          <a:fontRef idx="minor">
+            <a:schemeClr val="lt1"/>
+          </a:fontRef>
+        </p:style>
+        <p:txBody>
+          <a:bodyPr rtlCol="0" anchor="ctr"/>
+          <a:lstStyle/>
+          <a:p>
+            <a:pPr algn="ctr"/>
+          </a:p>
+        </p:txBody>
+      </p:sp>
+      <p:sp>
+        <p:nvSpPr>
+          <p:cNvPr id="3" name="TextBox 2"/>
+          <p:cNvSpPr txBox="1"/>
+          <p:nvPr/>
+        </p:nvSpPr>
+        <p:spPr>
+          <a:xfrm>
+            <a:off x="1097280" y="384048"/>
+            <a:ext cx="10515600" cy="365760"/>
+          </a:xfrm>
+          <a:prstGeom prst="rect">
+            <a:avLst/>
+          </a:prstGeom>
+          <a:noFill/>
+        </p:spPr>
+        <p:txBody>
+          <a:bodyPr wrap="square">
+            <a:spAutoFit/>
+          </a:bodyPr>
+          <a:lstStyle/>
+          <a:p>
+            <a:pPr algn="l">
+              <a:spcAft>
+                <a:spcPts val="600"/>
+              </a:spcAft>
+            </a:pPr>
+            <a:r>
+              <a:rPr sz="1300" b="1">
+                <a:solidFill>
+                  <a:srgbClr val="3D3C38"/>
+                </a:solidFill>
+                <a:latin typeface="Arial"/>
+              </a:rPr>
+              <a:t>APPENDIX · DATA &amp; PREPARATION</a:t>
+            </a:r>
+          </a:p>
+        </p:txBody>
+      </p:sp>
+      <p:sp>
+        <p:nvSpPr>
+          <p:cNvPr id="4" name="TextBox 3"/>
+          <p:cNvSpPr txBox="1"/>
+          <p:nvPr/>
+        </p:nvSpPr>
+        <p:spPr>
+          <a:xfrm>
+            <a:off x="548640" y="777240"/>
+            <a:ext cx="11064240" cy="1005840"/>
+          </a:xfrm>
+          <a:prstGeom prst="rect">
+            <a:avLst/>
+          </a:prstGeom>
+          <a:noFill/>
+        </p:spPr>
+        <p:txBody>
+          <a:bodyPr wrap="square">
+            <a:spAutoFit/>
+          </a:bodyPr>
+          <a:lstStyle/>
+          <a:p>
+            <a:pPr algn="l">
+              <a:spcAft>
+                <a:spcPts val="600"/>
+              </a:spcAft>
+            </a:pPr>
+            <a:r>
+              <a:rPr sz="2900" b="1">
+                <a:solidFill>
+                  <a:srgbClr val="3D3C38"/>
+                </a:solidFill>
+                <a:latin typeface="Arial"/>
+              </a:rPr>
+              <a:t>Datasets, cleaning, integration</a:t>
+            </a:r>
+          </a:p>
+        </p:txBody>
+      </p:sp>
+      <p:sp>
+        <p:nvSpPr>
+          <p:cNvPr id="5" name="TextBox 4"/>
+          <p:cNvSpPr txBox="1"/>
+          <p:nvPr/>
+        </p:nvSpPr>
+        <p:spPr>
+          <a:xfrm>
+            <a:off x="548640" y="1691640"/>
+            <a:ext cx="11155680" cy="4297680"/>
+          </a:xfrm>
+          <a:prstGeom prst="rect">
+            <a:avLst/>
+          </a:prstGeom>
+          <a:noFill/>
+        </p:spPr>
+        <p:txBody>
+          <a:bodyPr wrap="square">
+            <a:spAutoFit/>
+          </a:bodyPr>
+          <a:lstStyle/>
+          <a:p>
+            <a:pPr>
+              <a:spcAft>
+                <a:spcPts val="1000"/>
+              </a:spcAft>
+            </a:pPr>
+            <a:r>
+              <a:rPr sz="1100">
+                <a:solidFill>
+                  <a:srgbClr val="FF612B"/>
+                </a:solidFill>
+                <a:latin typeface="Arial"/>
+              </a:rPr>
+              <a:t>■  </a:t>
+            </a:r>
+            <a:r>
+              <a:rPr sz="1300" b="1">
+                <a:solidFill>
+                  <a:srgbClr val="3D3C38"/>
+                </a:solidFill>
+                <a:latin typeface="Arial"/>
+              </a:rPr>
+              <a:t>Core: </a:t>
+            </a:r>
+            <a:r>
+              <a:rPr sz="1300" b="0">
+                <a:solidFill>
+                  <a:srgbClr val="3D3C38"/>
+                </a:solidFill>
+                <a:latin typeface="Arial"/>
+              </a:rPr>
+              <a:t>CMS Medicare Inpatient 146,427 provider×DRG + Outpatient 116,799 provider×APC; joined on CCN.</a:t>
+            </a:r>
+          </a:p>
+          <a:p>
+            <a:pPr>
+              <a:spcAft>
+                <a:spcPts val="1000"/>
+              </a:spcAft>
+            </a:pPr>
+            <a:r>
+              <a:rPr sz="1100">
+                <a:solidFill>
+                  <a:srgbClr val="FF612B"/>
+                </a:solidFill>
+                <a:latin typeface="Arial"/>
+              </a:rPr>
+              <a:t>■  </a:t>
+            </a:r>
+            <a:r>
+              <a:rPr sz="1300" b="1">
+                <a:solidFill>
+                  <a:srgbClr val="3D3C38"/>
+                </a:solidFill>
+                <a:latin typeface="Arial"/>
+              </a:rPr>
+              <a:t>Combined four ways: </a:t>
+            </a:r>
+            <a:r>
+              <a:rPr sz="1300" b="0">
+                <a:solidFill>
+                  <a:srgbClr val="3D3C38"/>
+                </a:solidFill>
+                <a:latin typeface="Arial"/>
+              </a:rPr>
+              <a:t>(1) separately at natural grain (within-DRG / within-APC outlier detection); (2) stacked long, ~210k rows (pooled cost-index, markup); (3) merged per-hospital, both settings (pricing-culture ρ=0.82, driver model); (4) a DRG+APC service-mix matrix (archetype network).</a:t>
+            </a:r>
+          </a:p>
+          <a:p>
+            <a:pPr>
+              <a:spcAft>
+                <a:spcPts val="1000"/>
+              </a:spcAft>
+            </a:pPr>
+            <a:r>
+              <a:rPr sz="1100">
+                <a:solidFill>
+                  <a:srgbClr val="FF612B"/>
+                </a:solidFill>
+                <a:latin typeface="Arial"/>
+              </a:rPr>
+              <a:t>■  </a:t>
+            </a:r>
+            <a:r>
+              <a:rPr sz="1300" b="1">
+                <a:solidFill>
+                  <a:srgbClr val="3D3C38"/>
+                </a:solidFill>
+                <a:latin typeface="Arial"/>
+              </a:rPr>
+              <a:t>Cleaning: </a:t>
+            </a:r>
+            <a:r>
+              <a:rPr sz="1300" b="0">
+                <a:solidFill>
+                  <a:srgbClr val="3D3C38"/>
+                </a:solidFill>
+                <a:latin typeface="Arial"/>
+              </a:rPr>
+              <a:t>Latin-1→UTF-8 re-encode, DECIMAL coercion, CCN zero-pad, RUCA=99 excluded, CMS cell-suppression noted, HCRIS total-margin artifact corrected.</a:t>
+            </a:r>
+          </a:p>
+          <a:p>
+            <a:pPr>
+              <a:spcAft>
+                <a:spcPts val="1000"/>
+              </a:spcAft>
+            </a:pPr>
+            <a:r>
+              <a:rPr sz="1100">
+                <a:solidFill>
+                  <a:srgbClr val="FF612B"/>
+                </a:solidFill>
+                <a:latin typeface="Arial"/>
+              </a:rPr>
+              <a:t>■  </a:t>
+            </a:r>
+            <a:r>
+              <a:rPr sz="1300" b="1">
+                <a:solidFill>
+                  <a:srgbClr val="3D3C38"/>
+                </a:solidFill>
+                <a:latin typeface="Arial"/>
+              </a:rPr>
+              <a:t>Supplements (all CMS): </a:t>
+            </a:r>
+            <a:r>
+              <a:rPr sz="1300" b="0">
+                <a:solidFill>
+                  <a:srgbClr val="3D3C38"/>
+                </a:solidFill>
+                <a:latin typeface="Arial"/>
+              </a:rPr>
+              <a:t>HCRIS cost report (ownership, margins), RUCA (urbanicity), public ZIP centroids (distance), Hospital Compare (quality stars).</a:t>
+            </a:r>
+          </a:p>
+          <a:p>
+            <a:pPr>
+              <a:spcAft>
+                <a:spcPts val="1000"/>
+              </a:spcAft>
+            </a:pPr>
+            <a:r>
+              <a:rPr sz="1100">
+                <a:solidFill>
+                  <a:srgbClr val="FF612B"/>
+                </a:solidFill>
+                <a:latin typeface="Arial"/>
+              </a:rPr>
+              <a:t>■  </a:t>
+            </a:r>
+            <a:r>
+              <a:rPr sz="1300" b="1">
+                <a:solidFill>
+                  <a:srgbClr val="3D3C38"/>
+                </a:solidFill>
+                <a:latin typeface="Arial"/>
+              </a:rPr>
+              <a:t>Distribution: </a:t>
+            </a:r>
+            <a:r>
+              <a:rPr sz="1300" b="0">
+                <a:solidFill>
+                  <a:srgbClr val="3D3C38"/>
+                </a:solidFill>
+                <a:latin typeface="Arial"/>
+              </a:rPr>
+              <a:t>submitted charge skew 12.5, kurtosis 535 → medians, logs and rank statistics throughout; never means/SD on raw dollars.</a:t>
+            </a:r>
+          </a:p>
+        </p:txBody>
+      </p:sp>
+    </p:spTree>
+  </p:cSld>
+  <p:clrMapOvr>
+    <a:masterClrMapping/>
+  </p:clrMapOvr>
+</p:sld>
+</file>
+
+<file path=ppt/slides/slide17.xml><?xml version="1.0" encoding="utf-8"?>
+<p:sld xmlns:a="http://schemas.openxmlformats.org/drawingml/2006/main" xmlns:p="http://schemas.openxmlformats.org/presentationml/2006/main" xmlns:r="http://schemas.openxmlformats.org/officeDocument/2006/relationships">
+  <p:cSld>
+    <p:bg>
+      <p:bgPr>
+        <a:solidFill>
+          <a:srgbClr val="FAF8F2"/>
+        </a:solidFill>
+        <a:effectLst/>
+      </p:bgPr>
+    </p:bg>
+    <p:spTree>
+      <p:nvGrpSpPr>
+        <p:cNvPr id="1" name=""/>
+        <p:cNvGrpSpPr/>
+        <p:nvPr/>
+      </p:nvGrpSpPr>
+      <p:grpSpPr/>
+      <p:sp>
+        <p:nvSpPr>
+          <p:cNvPr id="2" name="Rectangle 1"/>
+          <p:cNvSpPr/>
+          <p:nvPr/>
+        </p:nvSpPr>
+        <p:spPr>
+          <a:xfrm>
+            <a:off x="548640" y="502920"/>
+            <a:ext cx="457200" cy="109728"/>
+          </a:xfrm>
+          <a:prstGeom prst="rect">
+            <a:avLst/>
+          </a:prstGeom>
+          <a:solidFill>
+            <a:srgbClr val="FF612B"/>
+          </a:solidFill>
+          <a:ln>
+            <a:noFill/>
+          </a:ln>
+        </p:spPr>
+        <p:style>
+          <a:lnRef idx="1">
+            <a:schemeClr val="accent1"/>
+          </a:lnRef>
+          <a:fillRef idx="3">
+            <a:schemeClr val="accent1"/>
+          </a:fillRef>
+          <a:effectRef idx="2">
+            <a:schemeClr val="accent1"/>
+          </a:effectRef>
+          <a:fontRef idx="minor">
+            <a:schemeClr val="lt1"/>
+          </a:fontRef>
+        </p:style>
+        <p:txBody>
+          <a:bodyPr rtlCol="0" anchor="ctr"/>
+          <a:lstStyle/>
+          <a:p>
+            <a:pPr algn="ctr"/>
+          </a:p>
+        </p:txBody>
+      </p:sp>
+      <p:sp>
+        <p:nvSpPr>
+          <p:cNvPr id="3" name="TextBox 2"/>
+          <p:cNvSpPr txBox="1"/>
+          <p:nvPr/>
+        </p:nvSpPr>
+        <p:spPr>
+          <a:xfrm>
+            <a:off x="1097280" y="384048"/>
+            <a:ext cx="10515600" cy="365760"/>
+          </a:xfrm>
+          <a:prstGeom prst="rect">
+            <a:avLst/>
+          </a:prstGeom>
+          <a:noFill/>
+        </p:spPr>
+        <p:txBody>
+          <a:bodyPr wrap="square">
+            <a:spAutoFit/>
+          </a:bodyPr>
+          <a:lstStyle/>
+          <a:p>
+            <a:pPr algn="l">
+              <a:spcAft>
+                <a:spcPts val="600"/>
+              </a:spcAft>
+            </a:pPr>
+            <a:r>
+              <a:rPr sz="1300" b="1">
+                <a:solidFill>
+                  <a:srgbClr val="3D3C38"/>
+                </a:solidFill>
+                <a:latin typeface="Arial"/>
+              </a:rPr>
+              <a:t>APPENDIX · OUTLIER DETECTION</a:t>
+            </a:r>
+          </a:p>
+        </p:txBody>
+      </p:sp>
+      <p:sp>
+        <p:nvSpPr>
+          <p:cNvPr id="4" name="TextBox 3"/>
+          <p:cNvSpPr txBox="1"/>
+          <p:nvPr/>
+        </p:nvSpPr>
+        <p:spPr>
+          <a:xfrm>
+            <a:off x="548640" y="777240"/>
+            <a:ext cx="11064240" cy="1005840"/>
+          </a:xfrm>
+          <a:prstGeom prst="rect">
+            <a:avLst/>
+          </a:prstGeom>
+          <a:noFill/>
+        </p:spPr>
+        <p:txBody>
+          <a:bodyPr wrap="square">
+            <a:spAutoFit/>
+          </a:bodyPr>
+          <a:lstStyle/>
+          <a:p>
+            <a:pPr algn="l">
+              <a:spcAft>
+                <a:spcPts val="600"/>
+              </a:spcAft>
+            </a:pPr>
+            <a:r>
+              <a:rPr sz="2900" b="1">
+                <a:solidFill>
+                  <a:srgbClr val="3D3C38"/>
+                </a:solidFill>
+                <a:latin typeface="Arial"/>
+              </a:rPr>
+              <a:t>Peer-relative, archetype-adjusted — in both settings</a:t>
+            </a:r>
+          </a:p>
+        </p:txBody>
+      </p:sp>
+      <p:sp>
+        <p:nvSpPr>
+          <p:cNvPr id="5" name="TextBox 4"/>
+          <p:cNvSpPr txBox="1"/>
+          <p:nvPr/>
+        </p:nvSpPr>
+        <p:spPr>
+          <a:xfrm>
+            <a:off x="548640" y="1691640"/>
+            <a:ext cx="5577840" cy="4297680"/>
+          </a:xfrm>
+          <a:prstGeom prst="rect">
+            <a:avLst/>
+          </a:prstGeom>
+          <a:noFill/>
+        </p:spPr>
+        <p:txBody>
+          <a:bodyPr wrap="square">
+            <a:spAutoFit/>
+          </a:bodyPr>
+          <a:lstStyle/>
+          <a:p>
+            <a:pPr>
+              <a:spcAft>
+                <a:spcPts val="1000"/>
+              </a:spcAft>
+            </a:pPr>
+            <a:r>
+              <a:rPr sz="1100">
+                <a:solidFill>
+                  <a:srgbClr val="FF612B"/>
+                </a:solidFill>
+                <a:latin typeface="Arial"/>
+              </a:rPr>
+              <a:t>■  </a:t>
+            </a:r>
+            <a:r>
+              <a:rPr sz="1300" b="1">
+                <a:solidFill>
+                  <a:srgbClr val="3D3C38"/>
+                </a:solidFill>
+                <a:latin typeface="Arial"/>
+              </a:rPr>
+              <a:t>Service-grain: </a:t>
+            </a:r>
+            <a:r>
+              <a:rPr sz="1300" b="0">
+                <a:solidFill>
+                  <a:srgbClr val="3D3C38"/>
+                </a:solidFill>
+                <a:latin typeface="Arial"/>
+              </a:rPr>
+              <a:t>flag providers in the top 5% of submitted charge within each DRG (inpatient) and APC (outpatient); rank by number of services flagged.</a:t>
+            </a:r>
+          </a:p>
+          <a:p>
+            <a:pPr>
+              <a:spcAft>
+                <a:spcPts val="1000"/>
+              </a:spcAft>
+            </a:pPr>
+            <a:r>
+              <a:rPr sz="1100">
+                <a:solidFill>
+                  <a:srgbClr val="FF612B"/>
+                </a:solidFill>
+                <a:latin typeface="Arial"/>
+              </a:rPr>
+              <a:t>■  </a:t>
+            </a:r>
+            <a:r>
+              <a:rPr sz="1300" b="1">
+                <a:solidFill>
+                  <a:srgbClr val="3D3C38"/>
+                </a:solidFill>
+                <a:latin typeface="Arial"/>
+              </a:rPr>
+              <a:t>Defensible list: </a:t>
+            </a:r>
+            <a:r>
+              <a:rPr sz="1300" b="0">
+                <a:solidFill>
+                  <a:srgbClr val="3D3C38"/>
+                </a:solidFill>
+                <a:latin typeface="Arial"/>
+              </a:rPr>
+              <a:t>normalize each charge to the national median for that service, then a within-archetype robust modified-z (median + MAD) ≥ 3.5.</a:t>
+            </a:r>
+          </a:p>
+          <a:p>
+            <a:pPr>
+              <a:spcAft>
+                <a:spcPts val="1000"/>
+              </a:spcAft>
+            </a:pPr>
+            <a:r>
+              <a:rPr sz="1100">
+                <a:solidFill>
+                  <a:srgbClr val="FF612B"/>
+                </a:solidFill>
+                <a:latin typeface="Arial"/>
+              </a:rPr>
+              <a:t>■  </a:t>
+            </a:r>
+            <a:r>
+              <a:rPr sz="1300" b="1">
+                <a:solidFill>
+                  <a:srgbClr val="3D3C38"/>
+                </a:solidFill>
+                <a:latin typeface="Arial"/>
+              </a:rPr>
+              <a:t>Why archetype-adjusted: </a:t>
+            </a:r>
+            <a:r>
+              <a:rPr sz="1300" b="0">
+                <a:solidFill>
+                  <a:srgbClr val="3D3C38"/>
+                </a:solidFill>
+                <a:latin typeface="Arial"/>
+              </a:rPr>
+              <a:t>raw within-service detection over-flags academic centers (genuine case-mix); archetype-relative drops Cedars-Sinai, keeps Stanford + the for-profit chains.</a:t>
+            </a:r>
+          </a:p>
+          <a:p>
+            <a:pPr>
+              <a:spcAft>
+                <a:spcPts val="1000"/>
+              </a:spcAft>
+            </a:pPr>
+            <a:r>
+              <a:rPr sz="1100">
+                <a:solidFill>
+                  <a:srgbClr val="FF612B"/>
+                </a:solidFill>
+                <a:latin typeface="Arial"/>
+              </a:rPr>
+              <a:t>■  </a:t>
+            </a:r>
+            <a:r>
+              <a:rPr sz="1300" b="1">
+                <a:solidFill>
+                  <a:srgbClr val="3D3C38"/>
+                </a:solidFill>
+                <a:latin typeface="Arial"/>
+              </a:rPr>
+              <a:t>Repeat-offenders: </a:t>
+            </a:r>
+            <a:r>
+              <a:rPr sz="1300" b="0">
+                <a:solidFill>
+                  <a:srgbClr val="3D3C38"/>
+                </a:solidFill>
+                <a:latin typeface="Arial"/>
+              </a:rPr>
+              <a:t>high-confidence outliers price ~95% of their service lines above the national 90th percentile — a hospital-wide posture.</a:t>
+            </a:r>
+          </a:p>
+        </p:txBody>
+      </p:sp>
+      <p:graphicFrame>
+        <p:nvGraphicFramePr>
+          <p:cNvPr id="6" name="Table 5"/>
+          <p:cNvGraphicFramePr>
+            <a:graphicFrameLocks noGrp="1"/>
+          </p:cNvGraphicFramePr>
+          <p:nvPr/>
+        </p:nvGraphicFramePr>
+        <p:xfrm>
+          <a:off x="6400800" y="1828800"/>
+          <a:ext cx="5394960" cy="2194560"/>
+        </p:xfrm>
+        <a:graphic>
+          <a:graphicData uri="http://schemas.openxmlformats.org/drawingml/2006/table">
+            <a:tbl>
+              <a:tblPr firstRow="1" bandRow="1">
+                <a:tableStyleId>{5C22544A-7EE6-4342-B048-85BDC9FD1C3A}</a:tableStyleId>
+              </a:tblPr>
+              <a:tblGrid>
+                <a:gridCol w="2697480"/>
+                <a:gridCol w="2697480"/>
+              </a:tblGrid>
+              <a:tr h="313508">
+                <a:tc>
+                  <a:txBody>
+                    <a:bodyPr/>
+                    <a:lstStyle/>
+                    <a:p>
+                      <a:r>
+                        <a:rPr sz="1050" b="1">
+                          <a:solidFill>
+                            <a:srgbClr val="FAF8F2"/>
+                          </a:solidFill>
+                          <a:latin typeface="Arial"/>
+                        </a:rPr>
+                        <a:t>Cut</a:t>
+                      </a:r>
+                    </a:p>
+                  </a:txBody>
+                  <a:tcPr>
+                    <a:solidFill>
+                      <a:srgbClr val="3D3C38"/>
+                    </a:solidFill>
+                  </a:tcPr>
+                </a:tc>
+                <a:tc>
+                  <a:txBody>
+                    <a:bodyPr/>
+                    <a:lstStyle/>
+                    <a:p>
+                      <a:r>
+                        <a:rPr sz="1050" b="1">
+                          <a:solidFill>
+                            <a:srgbClr val="FAF8F2"/>
+                          </a:solidFill>
+                          <a:latin typeface="Arial"/>
+                        </a:rPr>
+                        <a:t>Flagged</a:t>
+                      </a:r>
+                    </a:p>
+                  </a:txBody>
+                  <a:tcPr>
+                    <a:solidFill>
+                      <a:srgbClr val="3D3C38"/>
+                    </a:solidFill>
+                  </a:tcPr>
+                </a:tc>
+              </a:tr>
+              <a:tr h="313508">
+                <a:tc>
+                  <a:txBody>
+                    <a:bodyPr/>
+                    <a:lstStyle/>
+                    <a:p>
+                      <a:r>
+                        <a:rPr sz="1050">
+                          <a:solidFill>
+                            <a:srgbClr val="3D3C38"/>
+                          </a:solidFill>
+                          <a:latin typeface="Arial"/>
+                        </a:rPr>
+                        <a:t>within-archetype p95</a:t>
+                      </a:r>
+                    </a:p>
+                  </a:txBody>
+                  <a:tcPr>
+                    <a:solidFill>
+                      <a:srgbClr val="FAF8F2"/>
+                    </a:solidFill>
+                  </a:tcPr>
+                </a:tc>
+                <a:tc>
+                  <a:txBody>
+                    <a:bodyPr/>
+                    <a:lstStyle/>
+                    <a:p>
+                      <a:r>
+                        <a:rPr sz="1050">
+                          <a:solidFill>
+                            <a:srgbClr val="3D3C38"/>
+                          </a:solidFill>
+                          <a:latin typeface="Arial"/>
+                        </a:rPr>
+                        <a:t>153</a:t>
+                      </a:r>
+                    </a:p>
+                  </a:txBody>
+                  <a:tcPr>
+                    <a:solidFill>
+                      <a:srgbClr val="FAF8F2"/>
+                    </a:solidFill>
+                  </a:tcPr>
+                </a:tc>
+              </a:tr>
+              <a:tr h="313508">
+                <a:tc>
+                  <a:txBody>
+                    <a:bodyPr/>
+                    <a:lstStyle/>
+                    <a:p>
+                      <a:r>
+                        <a:rPr sz="1050">
+                          <a:solidFill>
+                            <a:srgbClr val="3D3C38"/>
+                          </a:solidFill>
+                          <a:latin typeface="Arial"/>
+                        </a:rPr>
+                        <a:t>robust z ≥ 3.5 (high-conf)</a:t>
+                      </a:r>
+                    </a:p>
+                  </a:txBody>
+                  <a:tcPr>
+                    <a:solidFill>
+                      <a:srgbClr val="EDE8E0"/>
+                    </a:solidFill>
+                  </a:tcPr>
+                </a:tc>
+                <a:tc>
+                  <a:txBody>
+                    <a:bodyPr/>
+                    <a:lstStyle/>
+                    <a:p>
+                      <a:r>
+                        <a:rPr sz="1050">
+                          <a:solidFill>
+                            <a:srgbClr val="3D3C38"/>
+                          </a:solidFill>
+                          <a:latin typeface="Arial"/>
+                        </a:rPr>
+                        <a:t>11</a:t>
+                      </a:r>
+                    </a:p>
+                  </a:txBody>
+                  <a:tcPr>
+                    <a:solidFill>
+                      <a:srgbClr val="EDE8E0"/>
+                    </a:solidFill>
+                  </a:tcPr>
+                </a:tc>
+              </a:tr>
+              <a:tr h="313508">
+                <a:tc>
+                  <a:txBody>
+                    <a:bodyPr/>
+                    <a:lstStyle/>
+                    <a:p>
+                      <a:r>
+                        <a:rPr sz="1050">
+                          <a:solidFill>
+                            <a:srgbClr val="3D3C38"/>
+                          </a:solidFill>
+                          <a:latin typeface="Arial"/>
+                        </a:rPr>
+                        <a:t>plain-z ≥ 2 (foil)</a:t>
+                      </a:r>
+                    </a:p>
+                  </a:txBody>
+                  <a:tcPr>
+                    <a:solidFill>
+                      <a:srgbClr val="FAF8F2"/>
+                    </a:solidFill>
+                  </a:tcPr>
+                </a:tc>
+                <a:tc>
+                  <a:txBody>
+                    <a:bodyPr/>
+                    <a:lstStyle/>
+                    <a:p>
+                      <a:r>
+                        <a:rPr sz="1050">
+                          <a:solidFill>
+                            <a:srgbClr val="3D3C38"/>
+                          </a:solidFill>
+                          <a:latin typeface="Arial"/>
+                        </a:rPr>
+                        <a:t>83</a:t>
+                      </a:r>
+                    </a:p>
+                  </a:txBody>
+                  <a:tcPr>
+                    <a:solidFill>
+                      <a:srgbClr val="FAF8F2"/>
+                    </a:solidFill>
+                  </a:tcPr>
+                </a:tc>
+              </a:tr>
+              <a:tr h="313508">
+                <a:tc>
+                  <a:txBody>
+                    <a:bodyPr/>
+                    <a:lstStyle/>
+                    <a:p>
+                      <a:r>
+                        <a:rPr sz="1050">
+                          <a:solidFill>
+                            <a:srgbClr val="3D3C38"/>
+                          </a:solidFill>
+                          <a:latin typeface="Arial"/>
+                        </a:rPr>
+                        <a:t>chain: Capital Health / Carepoint</a:t>
+                      </a:r>
+                    </a:p>
+                  </a:txBody>
+                  <a:tcPr>
+                    <a:solidFill>
+                      <a:srgbClr val="EDE8E0"/>
+                    </a:solidFill>
+                  </a:tcPr>
+                </a:tc>
+                <a:tc>
+                  <a:txBody>
+                    <a:bodyPr/>
+                    <a:lstStyle/>
+                    <a:p>
+                      <a:r>
+                        <a:rPr sz="1050">
+                          <a:solidFill>
+                            <a:srgbClr val="3D3C38"/>
+                          </a:solidFill>
+                          <a:latin typeface="Arial"/>
+                        </a:rPr>
+                        <a:t>100%</a:t>
+                      </a:r>
+                    </a:p>
+                  </a:txBody>
+                  <a:tcPr>
+                    <a:solidFill>
+                      <a:srgbClr val="EDE8E0"/>
+                    </a:solidFill>
+                  </a:tcPr>
+                </a:tc>
+              </a:tr>
+              <a:tr h="313508">
+                <a:tc>
+                  <a:txBody>
+                    <a:bodyPr/>
+                    <a:lstStyle/>
+                    <a:p>
+                      <a:r>
+                        <a:rPr sz="1050">
+                          <a:solidFill>
+                            <a:srgbClr val="3D3C38"/>
+                          </a:solidFill>
+                          <a:latin typeface="Arial"/>
+                        </a:rPr>
+                        <a:t>chain: HCA</a:t>
+                      </a:r>
+                    </a:p>
+                  </a:txBody>
+                  <a:tcPr>
+                    <a:solidFill>
+                      <a:srgbClr val="FAF8F2"/>
+                    </a:solidFill>
+                  </a:tcPr>
+                </a:tc>
+                <a:tc>
+                  <a:txBody>
+                    <a:bodyPr/>
+                    <a:lstStyle/>
+                    <a:p>
+                      <a:r>
+                        <a:rPr sz="1050">
+                          <a:solidFill>
+                            <a:srgbClr val="3D3C38"/>
+                          </a:solidFill>
+                          <a:latin typeface="Arial"/>
+                        </a:rPr>
+                        <a:t>24%</a:t>
+                      </a:r>
+                    </a:p>
+                  </a:txBody>
+                  <a:tcPr>
+                    <a:solidFill>
+                      <a:srgbClr val="FAF8F2"/>
+                    </a:solidFill>
+                  </a:tcPr>
+                </a:tc>
+              </a:tr>
+              <a:tr h="313512">
+                <a:tc>
+                  <a:txBody>
+                    <a:bodyPr/>
+                    <a:lstStyle/>
+                    <a:p>
+                      <a:r>
+                        <a:rPr sz="1050">
+                          <a:solidFill>
+                            <a:srgbClr val="3D3C38"/>
+                          </a:solidFill>
+                          <a:latin typeface="Arial"/>
+                        </a:rPr>
+                        <a:t>independents</a:t>
+                      </a:r>
+                    </a:p>
+                  </a:txBody>
+                  <a:tcPr>
+                    <a:solidFill>
+                      <a:srgbClr val="EDE8E0"/>
+                    </a:solidFill>
+                  </a:tcPr>
+                </a:tc>
+                <a:tc>
+                  <a:txBody>
+                    <a:bodyPr/>
+                    <a:lstStyle/>
+                    <a:p>
+                      <a:r>
+                        <a:rPr sz="1050">
+                          <a:solidFill>
+                            <a:srgbClr val="3D3C38"/>
+                          </a:solidFill>
+                          <a:latin typeface="Arial"/>
+                        </a:rPr>
+                        <a:t>4.5%</a:t>
+                      </a:r>
+                    </a:p>
+                  </a:txBody>
+                  <a:tcPr>
+                    <a:solidFill>
+                      <a:srgbClr val="EDE8E0"/>
+                    </a:solidFill>
+                  </a:tcPr>
+                </a:tc>
+              </a:tr>
+            </a:tbl>
+          </a:graphicData>
+        </a:graphic>
+      </p:graphicFrame>
+    </p:spTree>
+  </p:cSld>
+  <p:clrMapOvr>
+    <a:masterClrMapping/>
+  </p:clrMapOvr>
+</p:sld>
+</file>
+
+<file path=ppt/slides/slide18.xml><?xml version="1.0" encoding="utf-8"?>
+<p:sld xmlns:a="http://schemas.openxmlformats.org/drawingml/2006/main" xmlns:p="http://schemas.openxmlformats.org/presentationml/2006/main" xmlns:r="http://schemas.openxmlformats.org/officeDocument/2006/relationships">
+  <p:cSld>
+    <p:bg>
+      <p:bgPr>
+        <a:solidFill>
+          <a:srgbClr val="FAF8F2"/>
+        </a:solidFill>
+        <a:effectLst/>
+      </p:bgPr>
+    </p:bg>
+    <p:spTree>
+      <p:nvGrpSpPr>
+        <p:cNvPr id="1" name=""/>
+        <p:cNvGrpSpPr/>
+        <p:nvPr/>
+      </p:nvGrpSpPr>
+      <p:grpSpPr/>
+      <p:sp>
+        <p:nvSpPr>
+          <p:cNvPr id="2" name="Rectangle 1"/>
+          <p:cNvSpPr/>
+          <p:nvPr/>
+        </p:nvSpPr>
+        <p:spPr>
+          <a:xfrm>
+            <a:off x="548640" y="502920"/>
+            <a:ext cx="457200" cy="109728"/>
+          </a:xfrm>
+          <a:prstGeom prst="rect">
+            <a:avLst/>
+          </a:prstGeom>
+          <a:solidFill>
+            <a:srgbClr val="FF612B"/>
+          </a:solidFill>
+          <a:ln>
+            <a:noFill/>
+          </a:ln>
+        </p:spPr>
+        <p:style>
+          <a:lnRef idx="1">
+            <a:schemeClr val="accent1"/>
+          </a:lnRef>
+          <a:fillRef idx="3">
+            <a:schemeClr val="accent1"/>
+          </a:fillRef>
+          <a:effectRef idx="2">
+            <a:schemeClr val="accent1"/>
+          </a:effectRef>
+          <a:fontRef idx="minor">
+            <a:schemeClr val="lt1"/>
+          </a:fontRef>
+        </p:style>
+        <p:txBody>
+          <a:bodyPr rtlCol="0" anchor="ctr"/>
+          <a:lstStyle/>
+          <a:p>
+            <a:pPr algn="ctr"/>
+          </a:p>
+        </p:txBody>
+      </p:sp>
+      <p:sp>
+        <p:nvSpPr>
+          <p:cNvPr id="3" name="TextBox 2"/>
+          <p:cNvSpPr txBox="1"/>
+          <p:nvPr/>
+        </p:nvSpPr>
+        <p:spPr>
+          <a:xfrm>
+            <a:off x="1097280" y="384048"/>
+            <a:ext cx="10515600" cy="365760"/>
+          </a:xfrm>
+          <a:prstGeom prst="rect">
+            <a:avLst/>
+          </a:prstGeom>
+          <a:noFill/>
+        </p:spPr>
+        <p:txBody>
+          <a:bodyPr wrap="square">
+            <a:spAutoFit/>
+          </a:bodyPr>
+          <a:lstStyle/>
+          <a:p>
+            <a:pPr algn="l">
+              <a:spcAft>
+                <a:spcPts val="600"/>
+              </a:spcAft>
+            </a:pPr>
+            <a:r>
+              <a:rPr sz="1300" b="1">
+                <a:solidFill>
+                  <a:srgbClr val="3D3C38"/>
+                </a:solidFill>
+                <a:latin typeface="Arial"/>
+              </a:rPr>
+              <a:t>APPENDIX · SERVICE-MIX NETWORK</a:t>
+            </a:r>
+          </a:p>
+        </p:txBody>
+      </p:sp>
+      <p:sp>
+        <p:nvSpPr>
+          <p:cNvPr id="4" name="TextBox 3"/>
+          <p:cNvSpPr txBox="1"/>
+          <p:nvPr/>
+        </p:nvSpPr>
+        <p:spPr>
+          <a:xfrm>
+            <a:off x="548640" y="777240"/>
+            <a:ext cx="11064240" cy="1005840"/>
+          </a:xfrm>
+          <a:prstGeom prst="rect">
+            <a:avLst/>
+          </a:prstGeom>
+          <a:noFill/>
+        </p:spPr>
+        <p:txBody>
+          <a:bodyPr wrap="square">
+            <a:spAutoFit/>
+          </a:bodyPr>
+          <a:lstStyle/>
+          <a:p>
+            <a:pPr algn="l">
+              <a:spcAft>
+                <a:spcPts val="600"/>
+              </a:spcAft>
+            </a:pPr>
+            <a:r>
+              <a:rPr sz="2900" b="1">
+                <a:solidFill>
+                  <a:srgbClr val="3D3C38"/>
+                </a:solidFill>
+                <a:latin typeface="Arial"/>
+              </a:rPr>
+              <a:t>Archetypes from how hospitals actually deliver care</a:t>
+            </a:r>
+          </a:p>
+        </p:txBody>
+      </p:sp>
+      <p:sp>
+        <p:nvSpPr>
+          <p:cNvPr id="5" name="TextBox 4"/>
+          <p:cNvSpPr txBox="1"/>
+          <p:nvPr/>
+        </p:nvSpPr>
+        <p:spPr>
+          <a:xfrm>
+            <a:off x="548640" y="1691640"/>
+            <a:ext cx="11155680" cy="4297680"/>
+          </a:xfrm>
+          <a:prstGeom prst="rect">
+            <a:avLst/>
+          </a:prstGeom>
+          <a:noFill/>
+        </p:spPr>
+        <p:txBody>
+          <a:bodyPr wrap="square">
+            <a:spAutoFit/>
+          </a:bodyPr>
+          <a:lstStyle/>
+          <a:p>
+            <a:pPr>
+              <a:spcAft>
+                <a:spcPts val="1000"/>
+              </a:spcAft>
+            </a:pPr>
+            <a:r>
+              <a:rPr sz="1100">
+                <a:solidFill>
+                  <a:srgbClr val="FF612B"/>
+                </a:solidFill>
+                <a:latin typeface="Arial"/>
+              </a:rPr>
+              <a:t>■  </a:t>
+            </a:r>
+            <a:r>
+              <a:rPr sz="1300" b="1">
+                <a:solidFill>
+                  <a:srgbClr val="3D3C38"/>
+                </a:solidFill>
+                <a:latin typeface="Arial"/>
+              </a:rPr>
+              <a:t>Construction: </a:t>
+            </a:r>
+            <a:r>
+              <a:rPr sz="1300" b="0">
+                <a:solidFill>
+                  <a:srgbClr val="3D3C38"/>
+                </a:solidFill>
+                <a:latin typeface="Arial"/>
+              </a:rPr>
+              <a:t>each hospital = its DRG/APC service-mix vector (3,236 hospitals × 602 codes); cosine similarity → k-nearest-neighbour graph (k=10).</a:t>
+            </a:r>
+          </a:p>
+          <a:p>
+            <a:pPr>
+              <a:spcAft>
+                <a:spcPts val="1000"/>
+              </a:spcAft>
+            </a:pPr>
+            <a:r>
+              <a:rPr sz="1100">
+                <a:solidFill>
+                  <a:srgbClr val="FF612B"/>
+                </a:solidFill>
+                <a:latin typeface="Arial"/>
+              </a:rPr>
+              <a:t>■  </a:t>
+            </a:r>
+            <a:r>
+              <a:rPr sz="1300" b="1">
+                <a:solidFill>
+                  <a:srgbClr val="3D3C38"/>
+                </a:solidFill>
+                <a:latin typeface="Arial"/>
+              </a:rPr>
+              <a:t>Communities: </a:t>
+            </a:r>
+            <a:r>
+              <a:rPr sz="1300" b="0">
+                <a:solidFill>
+                  <a:srgbClr val="3D3C38"/>
+                </a:solidFill>
+                <a:latin typeface="Arial"/>
+              </a:rPr>
+              <a:t>Louvain detection → 14 communities at modularity 0.704 (strong separation); signature-service lift names them — academic/tertiary, generalist, surgical-specialty, rural, behavioral, rehab.</a:t>
+            </a:r>
+          </a:p>
+          <a:p>
+            <a:pPr>
+              <a:spcAft>
+                <a:spcPts val="1000"/>
+              </a:spcAft>
+            </a:pPr>
+            <a:r>
+              <a:rPr sz="1100">
+                <a:solidFill>
+                  <a:srgbClr val="FF612B"/>
+                </a:solidFill>
+                <a:latin typeface="Arial"/>
+              </a:rPr>
+              <a:t>■  </a:t>
+            </a:r>
+            <a:r>
+              <a:rPr sz="1300" b="1">
+                <a:solidFill>
+                  <a:srgbClr val="3D3C38"/>
+                </a:solidFill>
+                <a:latin typeface="Arial"/>
+              </a:rPr>
+              <a:t>Cross-checks: </a:t>
+            </a:r>
+            <a:r>
+              <a:rPr sz="1300" b="0">
+                <a:solidFill>
+                  <a:srgbClr val="3D3C38"/>
+                </a:solidFill>
+                <a:latin typeface="Arial"/>
+              </a:rPr>
+              <a:t>PCA (variance spread across many components) and k-means independently recover the coarse generalist-core / specialty-periphery structure — not a Louvain artifact.</a:t>
+            </a:r>
+          </a:p>
+          <a:p>
+            <a:pPr>
+              <a:spcAft>
+                <a:spcPts val="1000"/>
+              </a:spcAft>
+            </a:pPr>
+            <a:r>
+              <a:rPr sz="1100">
+                <a:solidFill>
+                  <a:srgbClr val="FF612B"/>
+                </a:solidFill>
+                <a:latin typeface="Arial"/>
+              </a:rPr>
+              <a:t>■  </a:t>
+            </a:r>
+            <a:r>
+              <a:rPr sz="1300" b="1">
+                <a:solidFill>
+                  <a:srgbClr val="3D3C38"/>
+                </a:solidFill>
+                <a:latin typeface="Arial"/>
+              </a:rPr>
+              <a:t>Use: </a:t>
+            </a:r>
+            <a:r>
+              <a:rPr sz="1300" b="0">
+                <a:solidFill>
+                  <a:srgbClr val="3D3C38"/>
+                </a:solidFill>
+                <a:latin typeface="Arial"/>
+              </a:rPr>
+              <a:t>archetype membership defines the peer set for the outlier and steerage analysis.</a:t>
+            </a:r>
+          </a:p>
+        </p:txBody>
+      </p:sp>
+    </p:spTree>
+  </p:cSld>
+  <p:clrMapOvr>
+    <a:masterClrMapping/>
+  </p:clrMapOvr>
+</p:sld>
+</file>
+
+<file path=ppt/slides/slide19.xml><?xml version="1.0" encoding="utf-8"?>
+<p:sld xmlns:a="http://schemas.openxmlformats.org/drawingml/2006/main" xmlns:p="http://schemas.openxmlformats.org/presentationml/2006/main" xmlns:r="http://schemas.openxmlformats.org/officeDocument/2006/relationships">
+  <p:cSld>
+    <p:bg>
+      <p:bgPr>
+        <a:solidFill>
+          <a:srgbClr val="FAF8F2"/>
+        </a:solidFill>
+        <a:effectLst/>
+      </p:bgPr>
+    </p:bg>
+    <p:spTree>
+      <p:nvGrpSpPr>
+        <p:cNvPr id="1" name=""/>
+        <p:cNvGrpSpPr/>
+        <p:nvPr/>
+      </p:nvGrpSpPr>
+      <p:grpSpPr/>
+      <p:sp>
+        <p:nvSpPr>
+          <p:cNvPr id="2" name="Rectangle 1"/>
+          <p:cNvSpPr/>
+          <p:nvPr/>
+        </p:nvSpPr>
+        <p:spPr>
+          <a:xfrm>
+            <a:off x="548640" y="502920"/>
+            <a:ext cx="457200" cy="109728"/>
+          </a:xfrm>
+          <a:prstGeom prst="rect">
+            <a:avLst/>
+          </a:prstGeom>
+          <a:solidFill>
+            <a:srgbClr val="FF612B"/>
+          </a:solidFill>
+          <a:ln>
+            <a:noFill/>
+          </a:ln>
+        </p:spPr>
+        <p:style>
+          <a:lnRef idx="1">
+            <a:schemeClr val="accent1"/>
+          </a:lnRef>
+          <a:fillRef idx="3">
+            <a:schemeClr val="accent1"/>
+          </a:fillRef>
+          <a:effectRef idx="2">
+            <a:schemeClr val="accent1"/>
+          </a:effectRef>
+          <a:fontRef idx="minor">
+            <a:schemeClr val="lt1"/>
+          </a:fontRef>
+        </p:style>
+        <p:txBody>
+          <a:bodyPr rtlCol="0" anchor="ctr"/>
+          <a:lstStyle/>
+          <a:p>
+            <a:pPr algn="ctr"/>
+          </a:p>
+        </p:txBody>
+      </p:sp>
+      <p:sp>
+        <p:nvSpPr>
+          <p:cNvPr id="3" name="TextBox 2"/>
+          <p:cNvSpPr txBox="1"/>
+          <p:nvPr/>
+        </p:nvSpPr>
+        <p:spPr>
+          <a:xfrm>
+            <a:off x="1097280" y="384048"/>
+            <a:ext cx="10515600" cy="365760"/>
+          </a:xfrm>
+          <a:prstGeom prst="rect">
+            <a:avLst/>
+          </a:prstGeom>
+          <a:noFill/>
+        </p:spPr>
+        <p:txBody>
+          <a:bodyPr wrap="square">
+            <a:spAutoFit/>
+          </a:bodyPr>
+          <a:lstStyle/>
+          <a:p>
+            <a:pPr algn="l">
+              <a:spcAft>
+                <a:spcPts val="600"/>
+              </a:spcAft>
+            </a:pPr>
+            <a:r>
+              <a:rPr sz="1300" b="1">
+                <a:solidFill>
+                  <a:srgbClr val="3D3C38"/>
+                </a:solidFill>
+                <a:latin typeface="Arial"/>
+              </a:rPr>
+              <a:t>APPENDIX · COST-DRIVER MODEL</a:t>
+            </a:r>
+          </a:p>
+        </p:txBody>
+      </p:sp>
+      <p:sp>
+        <p:nvSpPr>
+          <p:cNvPr id="4" name="TextBox 3"/>
+          <p:cNvSpPr txBox="1"/>
+          <p:nvPr/>
+        </p:nvSpPr>
+        <p:spPr>
+          <a:xfrm>
+            <a:off x="548640" y="777240"/>
+            <a:ext cx="11064240" cy="1005840"/>
+          </a:xfrm>
+          <a:prstGeom prst="rect">
+            <a:avLst/>
+          </a:prstGeom>
+          <a:noFill/>
+        </p:spPr>
+        <p:txBody>
+          <a:bodyPr wrap="square">
+            <a:spAutoFit/>
+          </a:bodyPr>
+          <a:lstStyle/>
+          <a:p>
+            <a:pPr algn="l">
+              <a:spcAft>
+                <a:spcPts val="600"/>
+              </a:spcAft>
+            </a:pPr>
+            <a:r>
+              <a:rPr sz="2900" b="1">
+                <a:solidFill>
+                  <a:srgbClr val="3D3C38"/>
+                </a:solidFill>
+                <a:latin typeface="Arial"/>
+              </a:rPr>
+              <a:t>Leakage-free, triangulated, decision-relevant metrics</a:t>
+            </a:r>
+          </a:p>
+        </p:txBody>
+      </p:sp>
+      <p:sp>
+        <p:nvSpPr>
+          <p:cNvPr id="5" name="TextBox 4"/>
+          <p:cNvSpPr txBox="1"/>
+          <p:nvPr/>
+        </p:nvSpPr>
+        <p:spPr>
+          <a:xfrm>
+            <a:off x="548640" y="1600200"/>
+            <a:ext cx="11155680" cy="4297680"/>
+          </a:xfrm>
+          <a:prstGeom prst="rect">
+            <a:avLst/>
+          </a:prstGeom>
+          <a:noFill/>
+        </p:spPr>
+        <p:txBody>
+          <a:bodyPr wrap="square">
+            <a:spAutoFit/>
+          </a:bodyPr>
+          <a:lstStyle/>
+          <a:p>
+            <a:pPr>
+              <a:spcAft>
+                <a:spcPts val="1000"/>
+              </a:spcAft>
+            </a:pPr>
+            <a:r>
+              <a:rPr sz="1100">
+                <a:solidFill>
+                  <a:srgbClr val="FF612B"/>
+                </a:solidFill>
+                <a:latin typeface="Arial"/>
+              </a:rPr>
+              <a:t>■  </a:t>
+            </a:r>
+            <a:r>
+              <a:rPr sz="1300" b="1">
+                <a:solidFill>
+                  <a:srgbClr val="3D3C38"/>
+                </a:solidFill>
+                <a:latin typeface="Arial"/>
+              </a:rPr>
+              <a:t>Design: </a:t>
+            </a:r>
+            <a:r>
+              <a:rPr sz="1300" b="0">
+                <a:solidFill>
+                  <a:srgbClr val="3D3C38"/>
+                </a:solidFill>
+                <a:latin typeface="Arial"/>
+              </a:rPr>
+              <a:t>provider grain (n=2,933); a discharge-weighted case-mix index preserves the DRG signal without service-grain leakage.</a:t>
+            </a:r>
+          </a:p>
+          <a:p>
+            <a:pPr>
+              <a:spcAft>
+                <a:spcPts val="1000"/>
+              </a:spcAft>
+            </a:pPr>
+            <a:r>
+              <a:rPr sz="1100">
+                <a:solidFill>
+                  <a:srgbClr val="FF612B"/>
+                </a:solidFill>
+                <a:latin typeface="Arial"/>
+              </a:rPr>
+              <a:t>■  </a:t>
+            </a:r>
+            <a:r>
+              <a:rPr sz="1300" b="1">
+                <a:solidFill>
+                  <a:srgbClr val="3D3C38"/>
+                </a:solidFill>
+                <a:latin typeface="Arial"/>
+              </a:rPr>
+              <a:t>Importance: </a:t>
+            </a:r>
+            <a:r>
+              <a:rPr sz="1300" b="0">
+                <a:solidFill>
+                  <a:srgbClr val="3D3C38"/>
+                </a:solidFill>
+                <a:latin typeface="Arial"/>
+              </a:rPr>
+              <a:t>interventional SHAP + permutation + glass-box EBM agree and are seed-stable across 5 seeds: state &gt; case-mix &gt; ownership; volume negligible.</a:t>
+            </a:r>
+          </a:p>
+          <a:p>
+            <a:pPr>
+              <a:spcAft>
+                <a:spcPts val="1000"/>
+              </a:spcAft>
+            </a:pPr>
+            <a:r>
+              <a:rPr sz="1100">
+                <a:solidFill>
+                  <a:srgbClr val="FF612B"/>
+                </a:solidFill>
+                <a:latin typeface="Arial"/>
+              </a:rPr>
+              <a:t>■  </a:t>
+            </a:r>
+            <a:r>
+              <a:rPr sz="1300" b="1">
+                <a:solidFill>
+                  <a:srgbClr val="3D3C38"/>
+                </a:solidFill>
+                <a:latin typeface="Arial"/>
+              </a:rPr>
+              <a:t>Metrics: </a:t>
+            </a:r>
+            <a:r>
+              <a:rPr sz="1300" b="0">
+                <a:solidFill>
+                  <a:srgbClr val="3D3C38"/>
+                </a:solidFill>
+                <a:latin typeface="Arial"/>
+              </a:rPr>
+              <a:t>5-fold CV, reported as MAE + back-transformed dollar error — not R² alone (R² on a log target flatters fit).</a:t>
+            </a:r>
+          </a:p>
+        </p:txBody>
+      </p:sp>
+      <p:graphicFrame>
+        <p:nvGraphicFramePr>
+          <p:cNvPr id="6" name="Table 5"/>
+          <p:cNvGraphicFramePr>
+            <a:graphicFrameLocks noGrp="1"/>
+          </p:cNvGraphicFramePr>
+          <p:nvPr/>
+        </p:nvGraphicFramePr>
+        <p:xfrm>
+          <a:off x="548640" y="3200400"/>
+          <a:ext cx="7863840" cy="1371600"/>
+        </p:xfrm>
+        <a:graphic>
+          <a:graphicData uri="http://schemas.openxmlformats.org/drawingml/2006/table">
+            <a:tbl>
+              <a:tblPr firstRow="1" bandRow="1">
+                <a:tableStyleId>{5C22544A-7EE6-4342-B048-85BDC9FD1C3A}</a:tableStyleId>
+              </a:tblPr>
+              <a:tblGrid>
+                <a:gridCol w="1572768"/>
+                <a:gridCol w="1572768"/>
+                <a:gridCol w="1572768"/>
+                <a:gridCol w="1572768"/>
+                <a:gridCol w="1572768"/>
+              </a:tblGrid>
+              <a:tr h="342900">
+                <a:tc>
+                  <a:txBody>
+                    <a:bodyPr/>
+                    <a:lstStyle/>
+                    <a:p>
+                      <a:r>
+                        <a:rPr sz="1050" b="1">
+                          <a:solidFill>
+                            <a:srgbClr val="FAF8F2"/>
+                          </a:solidFill>
+                          <a:latin typeface="Arial"/>
+                        </a:rPr>
+                        <a:t>Model (5-fold CV)</a:t>
+                      </a:r>
+                    </a:p>
+                  </a:txBody>
+                  <a:tcPr>
+                    <a:solidFill>
+                      <a:srgbClr val="3D3C38"/>
+                    </a:solidFill>
+                  </a:tcPr>
+                </a:tc>
+                <a:tc>
+                  <a:txBody>
+                    <a:bodyPr/>
+                    <a:lstStyle/>
+                    <a:p>
+                      <a:r>
+                        <a:rPr sz="1050" b="1">
+                          <a:solidFill>
+                            <a:srgbClr val="FAF8F2"/>
+                          </a:solidFill>
+                          <a:latin typeface="Arial"/>
+                        </a:rPr>
+                        <a:t>R²(log)</a:t>
+                      </a:r>
+                    </a:p>
+                  </a:txBody>
+                  <a:tcPr>
+                    <a:solidFill>
+                      <a:srgbClr val="3D3C38"/>
+                    </a:solidFill>
+                  </a:tcPr>
+                </a:tc>
+                <a:tc>
+                  <a:txBody>
+                    <a:bodyPr/>
+                    <a:lstStyle/>
+                    <a:p>
+                      <a:r>
+                        <a:rPr sz="1050" b="1">
+                          <a:solidFill>
+                            <a:srgbClr val="FAF8F2"/>
+                          </a:solidFill>
+                          <a:latin typeface="Arial"/>
+                        </a:rPr>
+                        <a:t>MAE(log)</a:t>
+                      </a:r>
+                    </a:p>
+                  </a:txBody>
+                  <a:tcPr>
+                    <a:solidFill>
+                      <a:srgbClr val="3D3C38"/>
+                    </a:solidFill>
+                  </a:tcPr>
+                </a:tc>
+                <a:tc>
+                  <a:txBody>
+                    <a:bodyPr/>
+                    <a:lstStyle/>
+                    <a:p>
+                      <a:r>
+                        <a:rPr sz="1050" b="1">
+                          <a:solidFill>
+                            <a:srgbClr val="FAF8F2"/>
+                          </a:solidFill>
+                          <a:latin typeface="Arial"/>
+                        </a:rPr>
+                        <a:t>$ median err</a:t>
+                      </a:r>
+                    </a:p>
+                  </a:txBody>
+                  <a:tcPr>
+                    <a:solidFill>
+                      <a:srgbClr val="3D3C38"/>
+                    </a:solidFill>
+                  </a:tcPr>
+                </a:tc>
+                <a:tc>
+                  <a:txBody>
+                    <a:bodyPr/>
+                    <a:lstStyle/>
+                    <a:p>
+                      <a:r>
+                        <a:rPr sz="1050" b="1">
+                          <a:solidFill>
+                            <a:srgbClr val="FAF8F2"/>
+                          </a:solidFill>
+                          <a:latin typeface="Arial"/>
+                        </a:rPr>
+                        <a:t>$ MdAPE</a:t>
+                      </a:r>
+                    </a:p>
+                  </a:txBody>
+                  <a:tcPr>
+                    <a:solidFill>
+                      <a:srgbClr val="3D3C38"/>
+                    </a:solidFill>
+                  </a:tcPr>
+                </a:tc>
+              </a:tr>
+              <a:tr h="342900">
+                <a:tc>
+                  <a:txBody>
+                    <a:bodyPr/>
+                    <a:lstStyle/>
+                    <a:p>
+                      <a:r>
+                        <a:rPr sz="1050">
+                          <a:solidFill>
+                            <a:srgbClr val="3D3C38"/>
+                          </a:solidFill>
+                          <a:latin typeface="Arial"/>
+                        </a:rPr>
+                        <a:t>EBM (glass-box)</a:t>
+                      </a:r>
+                    </a:p>
+                  </a:txBody>
+                  <a:tcPr>
+                    <a:solidFill>
+                      <a:srgbClr val="FAF8F2"/>
+                    </a:solidFill>
+                  </a:tcPr>
+                </a:tc>
+                <a:tc>
+                  <a:txBody>
+                    <a:bodyPr/>
+                    <a:lstStyle/>
+                    <a:p>
+                      <a:r>
+                        <a:rPr sz="1050">
+                          <a:solidFill>
+                            <a:srgbClr val="3D3C38"/>
+                          </a:solidFill>
+                          <a:latin typeface="Arial"/>
+                        </a:rPr>
+                        <a:t>0.704 ± .015</a:t>
+                      </a:r>
+                    </a:p>
+                  </a:txBody>
+                  <a:tcPr>
+                    <a:solidFill>
+                      <a:srgbClr val="FAF8F2"/>
+                    </a:solidFill>
+                  </a:tcPr>
+                </a:tc>
+                <a:tc>
+                  <a:txBody>
+                    <a:bodyPr/>
+                    <a:lstStyle/>
+                    <a:p>
+                      <a:r>
+                        <a:rPr sz="1050">
+                          <a:solidFill>
+                            <a:srgbClr val="3D3C38"/>
+                          </a:solidFill>
+                          <a:latin typeface="Arial"/>
+                        </a:rPr>
+                        <a:t>0.270</a:t>
+                      </a:r>
+                    </a:p>
+                  </a:txBody>
+                  <a:tcPr>
+                    <a:solidFill>
+                      <a:srgbClr val="FAF8F2"/>
+                    </a:solidFill>
+                  </a:tcPr>
+                </a:tc>
+                <a:tc>
+                  <a:txBody>
+                    <a:bodyPr/>
+                    <a:lstStyle/>
+                    <a:p>
+                      <a:r>
+                        <a:rPr sz="1050">
+                          <a:solidFill>
+                            <a:srgbClr val="3D3C38"/>
+                          </a:solidFill>
+                          <a:latin typeface="Arial"/>
+                        </a:rPr>
+                        <a:t>$11,090</a:t>
+                      </a:r>
+                    </a:p>
+                  </a:txBody>
+                  <a:tcPr>
+                    <a:solidFill>
+                      <a:srgbClr val="FAF8F2"/>
+                    </a:solidFill>
+                  </a:tcPr>
+                </a:tc>
+                <a:tc>
+                  <a:txBody>
+                    <a:bodyPr/>
+                    <a:lstStyle/>
+                    <a:p>
+                      <a:r>
+                        <a:rPr sz="1050">
+                          <a:solidFill>
+                            <a:srgbClr val="3D3C38"/>
+                          </a:solidFill>
+                          <a:latin typeface="Arial"/>
+                        </a:rPr>
+                        <a:t>22%</a:t>
+                      </a:r>
+                    </a:p>
+                  </a:txBody>
+                  <a:tcPr>
+                    <a:solidFill>
+                      <a:srgbClr val="FAF8F2"/>
+                    </a:solidFill>
+                  </a:tcPr>
+                </a:tc>
+              </a:tr>
+              <a:tr h="342900">
+                <a:tc>
+                  <a:txBody>
+                    <a:bodyPr/>
+                    <a:lstStyle/>
+                    <a:p>
+                      <a:r>
+                        <a:rPr sz="1050">
+                          <a:solidFill>
+                            <a:srgbClr val="3D3C38"/>
+                          </a:solidFill>
+                          <a:latin typeface="Arial"/>
+                        </a:rPr>
+                        <a:t>LightGBM</a:t>
+                      </a:r>
+                    </a:p>
+                  </a:txBody>
+                  <a:tcPr>
+                    <a:solidFill>
+                      <a:srgbClr val="EDE8E0"/>
+                    </a:solidFill>
+                  </a:tcPr>
+                </a:tc>
+                <a:tc>
+                  <a:txBody>
+                    <a:bodyPr/>
+                    <a:lstStyle/>
+                    <a:p>
+                      <a:r>
+                        <a:rPr sz="1050">
+                          <a:solidFill>
+                            <a:srgbClr val="3D3C38"/>
+                          </a:solidFill>
+                          <a:latin typeface="Arial"/>
+                        </a:rPr>
+                        <a:t>0.678 ± .029</a:t>
+                      </a:r>
+                    </a:p>
+                  </a:txBody>
+                  <a:tcPr>
+                    <a:solidFill>
+                      <a:srgbClr val="EDE8E0"/>
+                    </a:solidFill>
+                  </a:tcPr>
+                </a:tc>
+                <a:tc>
+                  <a:txBody>
+                    <a:bodyPr/>
+                    <a:lstStyle/>
+                    <a:p>
+                      <a:r>
+                        <a:rPr sz="1050">
+                          <a:solidFill>
+                            <a:srgbClr val="3D3C38"/>
+                          </a:solidFill>
+                          <a:latin typeface="Arial"/>
+                        </a:rPr>
+                        <a:t>0.281</a:t>
+                      </a:r>
+                    </a:p>
+                  </a:txBody>
+                  <a:tcPr>
+                    <a:solidFill>
+                      <a:srgbClr val="EDE8E0"/>
+                    </a:solidFill>
+                  </a:tcPr>
+                </a:tc>
+                <a:tc>
+                  <a:txBody>
+                    <a:bodyPr/>
+                    <a:lstStyle/>
+                    <a:p>
+                      <a:r>
+                        <a:rPr sz="1050">
+                          <a:solidFill>
+                            <a:srgbClr val="3D3C38"/>
+                          </a:solidFill>
+                          <a:latin typeface="Arial"/>
+                        </a:rPr>
+                        <a:t>$11,503</a:t>
+                      </a:r>
+                    </a:p>
+                  </a:txBody>
+                  <a:tcPr>
+                    <a:solidFill>
+                      <a:srgbClr val="EDE8E0"/>
+                    </a:solidFill>
+                  </a:tcPr>
+                </a:tc>
+                <a:tc>
+                  <a:txBody>
+                    <a:bodyPr/>
+                    <a:lstStyle/>
+                    <a:p>
+                      <a:r>
+                        <a:rPr sz="1050">
+                          <a:solidFill>
+                            <a:srgbClr val="3D3C38"/>
+                          </a:solidFill>
+                          <a:latin typeface="Arial"/>
+                        </a:rPr>
+                        <a:t>22%</a:t>
+                      </a:r>
+                    </a:p>
+                  </a:txBody>
+                  <a:tcPr>
+                    <a:solidFill>
+                      <a:srgbClr val="EDE8E0"/>
+                    </a:solidFill>
+                  </a:tcPr>
+                </a:tc>
+              </a:tr>
+              <a:tr h="342900">
+                <a:tc>
+                  <a:txBody>
+                    <a:bodyPr/>
+                    <a:lstStyle/>
+                    <a:p>
+                      <a:r>
+                        <a:rPr sz="1050">
+                          <a:solidFill>
+                            <a:srgbClr val="3D3C38"/>
+                          </a:solidFill>
+                          <a:latin typeface="Arial"/>
+                        </a:rPr>
+                        <a:t>Lasso</a:t>
+                      </a:r>
+                    </a:p>
+                  </a:txBody>
+                  <a:tcPr>
+                    <a:solidFill>
+                      <a:srgbClr val="FAF8F2"/>
+                    </a:solidFill>
+                  </a:tcPr>
+                </a:tc>
+                <a:tc>
+                  <a:txBody>
+                    <a:bodyPr/>
+                    <a:lstStyle/>
+                    <a:p>
+                      <a:r>
+                        <a:rPr sz="1050">
+                          <a:solidFill>
+                            <a:srgbClr val="3D3C38"/>
+                          </a:solidFill>
+                          <a:latin typeface="Arial"/>
+                        </a:rPr>
+                        <a:t>0.584 ± .014</a:t>
+                      </a:r>
+                    </a:p>
+                  </a:txBody>
+                  <a:tcPr>
+                    <a:solidFill>
+                      <a:srgbClr val="FAF8F2"/>
+                    </a:solidFill>
+                  </a:tcPr>
+                </a:tc>
+                <a:tc>
+                  <a:txBody>
+                    <a:bodyPr/>
+                    <a:lstStyle/>
+                    <a:p>
+                      <a:r>
+                        <a:rPr sz="1050">
+                          <a:solidFill>
+                            <a:srgbClr val="3D3C38"/>
+                          </a:solidFill>
+                          <a:latin typeface="Arial"/>
+                        </a:rPr>
+                        <a:t>0.324</a:t>
+                      </a:r>
+                    </a:p>
+                  </a:txBody>
+                  <a:tcPr>
+                    <a:solidFill>
+                      <a:srgbClr val="FAF8F2"/>
+                    </a:solidFill>
+                  </a:tcPr>
+                </a:tc>
+                <a:tc>
+                  <a:txBody>
+                    <a:bodyPr/>
+                    <a:lstStyle/>
+                    <a:p>
+                      <a:r>
+                        <a:rPr sz="1050">
+                          <a:solidFill>
+                            <a:srgbClr val="3D3C38"/>
+                          </a:solidFill>
+                          <a:latin typeface="Arial"/>
+                        </a:rPr>
+                        <a:t>$13,592</a:t>
+                      </a:r>
+                    </a:p>
+                  </a:txBody>
+                  <a:tcPr>
+                    <a:solidFill>
+                      <a:srgbClr val="FAF8F2"/>
+                    </a:solidFill>
+                  </a:tcPr>
+                </a:tc>
+                <a:tc>
+                  <a:txBody>
+                    <a:bodyPr/>
+                    <a:lstStyle/>
+                    <a:p>
+                      <a:r>
+                        <a:rPr sz="1050">
+                          <a:solidFill>
+                            <a:srgbClr val="3D3C38"/>
+                          </a:solidFill>
+                          <a:latin typeface="Arial"/>
+                        </a:rPr>
+                        <a:t>27%</a:t>
+                      </a:r>
+                    </a:p>
+                  </a:txBody>
+                  <a:tcPr>
+                    <a:solidFill>
+                      <a:srgbClr val="FAF8F2"/>
+                    </a:solidFill>
+                  </a:tcPr>
+                </a:tc>
+              </a:tr>
+            </a:tbl>
+          </a:graphicData>
+        </a:graphic>
+      </p:graphicFrame>
+      <p:sp>
+        <p:nvSpPr>
+          <p:cNvPr id="7" name="TextBox 6"/>
+          <p:cNvSpPr txBox="1"/>
+          <p:nvPr/>
+        </p:nvSpPr>
+        <p:spPr>
+          <a:xfrm>
+            <a:off x="548640" y="4937760"/>
+            <a:ext cx="11155680" cy="1097280"/>
+          </a:xfrm>
+          <a:prstGeom prst="rect">
+            <a:avLst/>
+          </a:prstGeom>
+          <a:noFill/>
+        </p:spPr>
+        <p:txBody>
+          <a:bodyPr wrap="square">
+            <a:spAutoFit/>
+          </a:bodyPr>
+          <a:lstStyle/>
+          <a:p>
+            <a:pPr algn="l">
+              <a:spcAft>
+                <a:spcPts val="600"/>
+              </a:spcAft>
+            </a:pPr>
+            <a:r>
+              <a:rPr sz="1200" b="1">
+                <a:solidFill>
+                  <a:srgbClr val="3D3C38"/>
+                </a:solidFill>
+                <a:latin typeface="Arial"/>
+              </a:rPr>
+              <a:t>Variance decomposition (η²): </a:t>
+            </a:r>
+            <a:r>
+              <a:rPr sz="1200" b="0">
+                <a:solidFill>
+                  <a:srgbClr val="3D3C38"/>
+                </a:solidFill>
+                <a:latin typeface="Arial"/>
+              </a:rPr>
+              <a:t>log charge — DRG 0.578, state 0.180, urbanicity 0.040; log Medicare payment — DRG 0.869, state 0.054. Geography loads ~3× more on charges than on cost-based payment — the pricing-discretion signal.</a:t>
+            </a:r>
+          </a:p>
+        </p:txBody>
+      </p:sp>
+    </p:spTree>
+  </p:cSld>
+  <p:clrMapOvr>
+    <a:masterClrMapping/>
+  </p:clrMapOvr>
+</p:sld>
+</file>
+
 <file path=ppt/slides/slide2.xml><?xml version="1.0" encoding="utf-8"?>
 <p:sld xmlns:a="http://schemas.openxmlformats.org/drawingml/2006/main" xmlns:p="http://schemas.openxmlformats.org/presentationml/2006/main" xmlns:r="http://schemas.openxmlformats.org/officeDocument/2006/relationships">
   <p:cSld>
@@ -6035,6 +8368,1019 @@
                 <a:latin typeface="Arial"/>
               </a:rPr>
               <a:t>build the network around hospitals that are both affordable and high-quality — start where a cheaper, better option is already nearby.</a:t>
+            </a:r>
+          </a:p>
+        </p:txBody>
+      </p:sp>
+    </p:spTree>
+  </p:cSld>
+  <p:clrMapOvr>
+    <a:masterClrMapping/>
+  </p:clrMapOvr>
+</p:sld>
+</file>
+
+<file path=ppt/slides/slide20.xml><?xml version="1.0" encoding="utf-8"?>
+<p:sld xmlns:a="http://schemas.openxmlformats.org/drawingml/2006/main" xmlns:p="http://schemas.openxmlformats.org/presentationml/2006/main" xmlns:r="http://schemas.openxmlformats.org/officeDocument/2006/relationships">
+  <p:cSld>
+    <p:bg>
+      <p:bgPr>
+        <a:solidFill>
+          <a:srgbClr val="FAF8F2"/>
+        </a:solidFill>
+        <a:effectLst/>
+      </p:bgPr>
+    </p:bg>
+    <p:spTree>
+      <p:nvGrpSpPr>
+        <p:cNvPr id="1" name=""/>
+        <p:cNvGrpSpPr/>
+        <p:nvPr/>
+      </p:nvGrpSpPr>
+      <p:grpSpPr/>
+      <p:sp>
+        <p:nvSpPr>
+          <p:cNvPr id="2" name="Rectangle 1"/>
+          <p:cNvSpPr/>
+          <p:nvPr/>
+        </p:nvSpPr>
+        <p:spPr>
+          <a:xfrm>
+            <a:off x="548640" y="502920"/>
+            <a:ext cx="457200" cy="109728"/>
+          </a:xfrm>
+          <a:prstGeom prst="rect">
+            <a:avLst/>
+          </a:prstGeom>
+          <a:solidFill>
+            <a:srgbClr val="FF612B"/>
+          </a:solidFill>
+          <a:ln>
+            <a:noFill/>
+          </a:ln>
+        </p:spPr>
+        <p:style>
+          <a:lnRef idx="1">
+            <a:schemeClr val="accent1"/>
+          </a:lnRef>
+          <a:fillRef idx="3">
+            <a:schemeClr val="accent1"/>
+          </a:fillRef>
+          <a:effectRef idx="2">
+            <a:schemeClr val="accent1"/>
+          </a:effectRef>
+          <a:fontRef idx="minor">
+            <a:schemeClr val="lt1"/>
+          </a:fontRef>
+        </p:style>
+        <p:txBody>
+          <a:bodyPr rtlCol="0" anchor="ctr"/>
+          <a:lstStyle/>
+          <a:p>
+            <a:pPr algn="ctr"/>
+          </a:p>
+        </p:txBody>
+      </p:sp>
+      <p:sp>
+        <p:nvSpPr>
+          <p:cNvPr id="3" name="TextBox 2"/>
+          <p:cNvSpPr txBox="1"/>
+          <p:nvPr/>
+        </p:nvSpPr>
+        <p:spPr>
+          <a:xfrm>
+            <a:off x="1097280" y="384048"/>
+            <a:ext cx="10515600" cy="365760"/>
+          </a:xfrm>
+          <a:prstGeom prst="rect">
+            <a:avLst/>
+          </a:prstGeom>
+          <a:noFill/>
+        </p:spPr>
+        <p:txBody>
+          <a:bodyPr wrap="square">
+            <a:spAutoFit/>
+          </a:bodyPr>
+          <a:lstStyle/>
+          <a:p>
+            <a:pPr algn="l">
+              <a:spcAft>
+                <a:spcPts val="600"/>
+              </a:spcAft>
+            </a:pPr>
+            <a:r>
+              <a:rPr sz="1300" b="1">
+                <a:solidFill>
+                  <a:srgbClr val="3D3C38"/>
+                </a:solidFill>
+                <a:latin typeface="Arial"/>
+              </a:rPr>
+              <a:t>APPENDIX · FALSIFICATION &amp; QUALITY</a:t>
+            </a:r>
+          </a:p>
+        </p:txBody>
+      </p:sp>
+      <p:sp>
+        <p:nvSpPr>
+          <p:cNvPr id="4" name="TextBox 3"/>
+          <p:cNvSpPr txBox="1"/>
+          <p:nvPr/>
+        </p:nvSpPr>
+        <p:spPr>
+          <a:xfrm>
+            <a:off x="548640" y="777240"/>
+            <a:ext cx="11064240" cy="1005840"/>
+          </a:xfrm>
+          <a:prstGeom prst="rect">
+            <a:avLst/>
+          </a:prstGeom>
+          <a:noFill/>
+        </p:spPr>
+        <p:txBody>
+          <a:bodyPr wrap="square">
+            <a:spAutoFit/>
+          </a:bodyPr>
+          <a:lstStyle/>
+          <a:p>
+            <a:pPr algn="l">
+              <a:spcAft>
+                <a:spcPts val="600"/>
+              </a:spcAft>
+            </a:pPr>
+            <a:r>
+              <a:rPr sz="2900" b="1">
+                <a:solidFill>
+                  <a:srgbClr val="3D3C38"/>
+                </a:solidFill>
+                <a:latin typeface="Arial"/>
+              </a:rPr>
+              <a:t>Pricing-not-cost, and cost vs quality uncorrelated</a:t>
+            </a:r>
+          </a:p>
+        </p:txBody>
+      </p:sp>
+      <p:sp>
+        <p:nvSpPr>
+          <p:cNvPr id="5" name="TextBox 4"/>
+          <p:cNvSpPr txBox="1"/>
+          <p:nvPr/>
+        </p:nvSpPr>
+        <p:spPr>
+          <a:xfrm>
+            <a:off x="548640" y="1691640"/>
+            <a:ext cx="11155680" cy="4297680"/>
+          </a:xfrm>
+          <a:prstGeom prst="rect">
+            <a:avLst/>
+          </a:prstGeom>
+          <a:noFill/>
+        </p:spPr>
+        <p:txBody>
+          <a:bodyPr wrap="square">
+            <a:spAutoFit/>
+          </a:bodyPr>
+          <a:lstStyle/>
+          <a:p>
+            <a:pPr>
+              <a:spcAft>
+                <a:spcPts val="1000"/>
+              </a:spcAft>
+            </a:pPr>
+            <a:r>
+              <a:rPr sz="1100">
+                <a:solidFill>
+                  <a:srgbClr val="FF612B"/>
+                </a:solidFill>
+                <a:latin typeface="Arial"/>
+              </a:rPr>
+              <a:t>■  </a:t>
+            </a:r>
+            <a:r>
+              <a:rPr sz="1300" b="1">
+                <a:solidFill>
+                  <a:srgbClr val="3D3C38"/>
+                </a:solidFill>
+                <a:latin typeface="Arial"/>
+              </a:rPr>
+              <a:t>For-profit premium (nested OLS on log charge): </a:t>
+            </a:r>
+            <a:r>
+              <a:rPr sz="1300" b="0">
+                <a:solidFill>
+                  <a:srgbClr val="3D3C38"/>
+                </a:solidFill>
+                <a:latin typeface="Arial"/>
+              </a:rPr>
+              <a:t>+62.5% raw → +46.3% under full controls (case-mix, archetype, urbanicity, state); nonprofit −33%, government −34% vs for-profit.</a:t>
+            </a:r>
+          </a:p>
+          <a:p>
+            <a:pPr>
+              <a:spcAft>
+                <a:spcPts val="1000"/>
+              </a:spcAft>
+            </a:pPr>
+            <a:r>
+              <a:rPr sz="1100">
+                <a:solidFill>
+                  <a:srgbClr val="FF612B"/>
+                </a:solidFill>
+                <a:latin typeface="Arial"/>
+              </a:rPr>
+              <a:t>■  </a:t>
+            </a:r>
+            <a:r>
+              <a:rPr sz="1300" b="1">
+                <a:solidFill>
+                  <a:srgbClr val="3D3C38"/>
+                </a:solidFill>
+                <a:latin typeface="Arial"/>
+              </a:rPr>
+              <a:t>Falsification: </a:t>
+            </a:r>
+            <a:r>
+              <a:rPr sz="1300" b="0">
+                <a:solidFill>
+                  <a:srgbClr val="3D3C38"/>
+                </a:solidFill>
+                <a:latin typeface="Arial"/>
+              </a:rPr>
+              <a:t>under identical controls, +45% on submitted charge but −9% on wage-index-adjusted Medicare payment → markup, not cost. Pricing culture transfers IP↔OP (Spearman 0.82).</a:t>
+            </a:r>
+          </a:p>
+          <a:p>
+            <a:pPr>
+              <a:spcAft>
+                <a:spcPts val="1000"/>
+              </a:spcAft>
+            </a:pPr>
+            <a:r>
+              <a:rPr sz="1100">
+                <a:solidFill>
+                  <a:srgbClr val="FF612B"/>
+                </a:solidFill>
+                <a:latin typeface="Arial"/>
+              </a:rPr>
+              <a:t>■  </a:t>
+            </a:r>
+            <a:r>
+              <a:rPr sz="1300" b="1">
+                <a:solidFill>
+                  <a:srgbClr val="3D3C38"/>
+                </a:solidFill>
+                <a:latin typeface="Arial"/>
+              </a:rPr>
+              <a:t>Cost × quality (CMS Hospital Compare, n=2,616 rated): </a:t>
+            </a:r>
+            <a:r>
+              <a:rPr sz="1300" b="0">
+                <a:solidFill>
+                  <a:srgbClr val="3D3C38"/>
+                </a:solidFill>
+                <a:latin typeface="Arial"/>
+              </a:rPr>
+              <a:t>Spearman(cost, star) = −0.03; mean star by cost band 3.15 / 3.26 / 3.22 / 2.74 — the very-pricey tier is only 25% 4–5★.</a:t>
+            </a:r>
+          </a:p>
+          <a:p>
+            <a:pPr>
+              <a:spcAft>
+                <a:spcPts val="1000"/>
+              </a:spcAft>
+            </a:pPr>
+            <a:r>
+              <a:rPr sz="1100">
+                <a:solidFill>
+                  <a:srgbClr val="FF612B"/>
+                </a:solidFill>
+                <a:latin typeface="Arial"/>
+              </a:rPr>
+              <a:t>■  </a:t>
+            </a:r>
+            <a:r>
+              <a:rPr sz="1300" b="1">
+                <a:solidFill>
+                  <a:srgbClr val="3D3C38"/>
+                </a:solidFill>
+                <a:latin typeface="Arial"/>
+              </a:rPr>
+              <a:t>The 11 avoidances: </a:t>
+            </a:r>
+            <a:r>
+              <a:rPr sz="1300" b="0">
+                <a:solidFill>
+                  <a:srgbClr val="3D3C38"/>
+                </a:solidFill>
+                <a:latin typeface="Arial"/>
+              </a:rPr>
+              <a:t>7 of 10 rated are 1–2★ (steer-away doubly justified); Stanford 5★ and MLK 4★ are the quality-gate exceptions.</a:t>
+            </a:r>
+          </a:p>
+        </p:txBody>
+      </p:sp>
+    </p:spTree>
+  </p:cSld>
+  <p:clrMapOvr>
+    <a:masterClrMapping/>
+  </p:clrMapOvr>
+</p:sld>
+</file>
+
+<file path=ppt/slides/slide21.xml><?xml version="1.0" encoding="utf-8"?>
+<p:sld xmlns:a="http://schemas.openxmlformats.org/drawingml/2006/main" xmlns:p="http://schemas.openxmlformats.org/presentationml/2006/main" xmlns:r="http://schemas.openxmlformats.org/officeDocument/2006/relationships">
+  <p:cSld>
+    <p:bg>
+      <p:bgPr>
+        <a:solidFill>
+          <a:srgbClr val="FAF8F2"/>
+        </a:solidFill>
+        <a:effectLst/>
+      </p:bgPr>
+    </p:bg>
+    <p:spTree>
+      <p:nvGrpSpPr>
+        <p:cNvPr id="1" name=""/>
+        <p:cNvGrpSpPr/>
+        <p:nvPr/>
+      </p:nvGrpSpPr>
+      <p:grpSpPr/>
+      <p:sp>
+        <p:nvSpPr>
+          <p:cNvPr id="2" name="Rectangle 1"/>
+          <p:cNvSpPr/>
+          <p:nvPr/>
+        </p:nvSpPr>
+        <p:spPr>
+          <a:xfrm>
+            <a:off x="548640" y="502920"/>
+            <a:ext cx="457200" cy="109728"/>
+          </a:xfrm>
+          <a:prstGeom prst="rect">
+            <a:avLst/>
+          </a:prstGeom>
+          <a:solidFill>
+            <a:srgbClr val="FF612B"/>
+          </a:solidFill>
+          <a:ln>
+            <a:noFill/>
+          </a:ln>
+        </p:spPr>
+        <p:style>
+          <a:lnRef idx="1">
+            <a:schemeClr val="accent1"/>
+          </a:lnRef>
+          <a:fillRef idx="3">
+            <a:schemeClr val="accent1"/>
+          </a:fillRef>
+          <a:effectRef idx="2">
+            <a:schemeClr val="accent1"/>
+          </a:effectRef>
+          <a:fontRef idx="minor">
+            <a:schemeClr val="lt1"/>
+          </a:fontRef>
+        </p:style>
+        <p:txBody>
+          <a:bodyPr rtlCol="0" anchor="ctr"/>
+          <a:lstStyle/>
+          <a:p>
+            <a:pPr algn="ctr"/>
+          </a:p>
+        </p:txBody>
+      </p:sp>
+      <p:sp>
+        <p:nvSpPr>
+          <p:cNvPr id="3" name="TextBox 2"/>
+          <p:cNvSpPr txBox="1"/>
+          <p:nvPr/>
+        </p:nvSpPr>
+        <p:spPr>
+          <a:xfrm>
+            <a:off x="1097280" y="384048"/>
+            <a:ext cx="10515600" cy="365760"/>
+          </a:xfrm>
+          <a:prstGeom prst="rect">
+            <a:avLst/>
+          </a:prstGeom>
+          <a:noFill/>
+        </p:spPr>
+        <p:txBody>
+          <a:bodyPr wrap="square">
+            <a:spAutoFit/>
+          </a:bodyPr>
+          <a:lstStyle/>
+          <a:p>
+            <a:pPr algn="l">
+              <a:spcAft>
+                <a:spcPts val="600"/>
+              </a:spcAft>
+            </a:pPr>
+            <a:r>
+              <a:rPr sz="1300" b="1">
+                <a:solidFill>
+                  <a:srgbClr val="3D3C38"/>
+                </a:solidFill>
+                <a:latin typeface="Arial"/>
+              </a:rPr>
+              <a:t>APPENDIX · ROBUSTNESS &amp; LIMITATIONS</a:t>
+            </a:r>
+          </a:p>
+        </p:txBody>
+      </p:sp>
+      <p:sp>
+        <p:nvSpPr>
+          <p:cNvPr id="4" name="TextBox 3"/>
+          <p:cNvSpPr txBox="1"/>
+          <p:nvPr/>
+        </p:nvSpPr>
+        <p:spPr>
+          <a:xfrm>
+            <a:off x="548640" y="777240"/>
+            <a:ext cx="11064240" cy="1005840"/>
+          </a:xfrm>
+          <a:prstGeom prst="rect">
+            <a:avLst/>
+          </a:prstGeom>
+          <a:noFill/>
+        </p:spPr>
+        <p:txBody>
+          <a:bodyPr wrap="square">
+            <a:spAutoFit/>
+          </a:bodyPr>
+          <a:lstStyle/>
+          <a:p>
+            <a:pPr algn="l">
+              <a:spcAft>
+                <a:spcPts val="600"/>
+              </a:spcAft>
+            </a:pPr>
+            <a:r>
+              <a:rPr sz="2900" b="1">
+                <a:solidFill>
+                  <a:srgbClr val="3D3C38"/>
+                </a:solidFill>
+                <a:latin typeface="Arial"/>
+              </a:rPr>
+              <a:t>Holds out-of-year (2022); honest limits</a:t>
+            </a:r>
+          </a:p>
+        </p:txBody>
+      </p:sp>
+      <p:graphicFrame>
+        <p:nvGraphicFramePr>
+          <p:cNvPr id="5" name="Table 4"/>
+          <p:cNvGraphicFramePr>
+            <a:graphicFrameLocks noGrp="1"/>
+          </p:cNvGraphicFramePr>
+          <p:nvPr/>
+        </p:nvGraphicFramePr>
+        <p:xfrm>
+          <a:off x="548640" y="1645920"/>
+          <a:ext cx="7315200" cy="2286000"/>
+        </p:xfrm>
+        <a:graphic>
+          <a:graphicData uri="http://schemas.openxmlformats.org/drawingml/2006/table">
+            <a:tbl>
+              <a:tblPr firstRow="1" bandRow="1">
+                <a:tableStyleId>{5C22544A-7EE6-4342-B048-85BDC9FD1C3A}</a:tableStyleId>
+              </a:tblPr>
+              <a:tblGrid>
+                <a:gridCol w="2438400"/>
+                <a:gridCol w="2438400"/>
+                <a:gridCol w="2438400"/>
+              </a:tblGrid>
+              <a:tr h="326571">
+                <a:tc>
+                  <a:txBody>
+                    <a:bodyPr/>
+                    <a:lstStyle/>
+                    <a:p>
+                      <a:r>
+                        <a:rPr sz="1050" b="1">
+                          <a:solidFill>
+                            <a:srgbClr val="FAF8F2"/>
+                          </a:solidFill>
+                          <a:latin typeface="Arial"/>
+                        </a:rPr>
+                        <a:t>Finding</a:t>
+                      </a:r>
+                    </a:p>
+                  </a:txBody>
+                  <a:tcPr>
+                    <a:solidFill>
+                      <a:srgbClr val="3D3C38"/>
+                    </a:solidFill>
+                  </a:tcPr>
+                </a:tc>
+                <a:tc>
+                  <a:txBody>
+                    <a:bodyPr/>
+                    <a:lstStyle/>
+                    <a:p>
+                      <a:r>
+                        <a:rPr sz="1050" b="1">
+                          <a:solidFill>
+                            <a:srgbClr val="FAF8F2"/>
+                          </a:solidFill>
+                          <a:latin typeface="Arial"/>
+                        </a:rPr>
+                        <a:t>2022</a:t>
+                      </a:r>
+                    </a:p>
+                  </a:txBody>
+                  <a:tcPr>
+                    <a:solidFill>
+                      <a:srgbClr val="3D3C38"/>
+                    </a:solidFill>
+                  </a:tcPr>
+                </a:tc>
+                <a:tc>
+                  <a:txBody>
+                    <a:bodyPr/>
+                    <a:lstStyle/>
+                    <a:p>
+                      <a:r>
+                        <a:rPr sz="1050" b="1">
+                          <a:solidFill>
+                            <a:srgbClr val="FAF8F2"/>
+                          </a:solidFill>
+                          <a:latin typeface="Arial"/>
+                        </a:rPr>
+                        <a:t>2023</a:t>
+                      </a:r>
+                    </a:p>
+                  </a:txBody>
+                  <a:tcPr>
+                    <a:solidFill>
+                      <a:srgbClr val="3D3C38"/>
+                    </a:solidFill>
+                  </a:tcPr>
+                </a:tc>
+              </a:tr>
+              <a:tr h="326571">
+                <a:tc>
+                  <a:txBody>
+                    <a:bodyPr/>
+                    <a:lstStyle/>
+                    <a:p>
+                      <a:r>
+                        <a:rPr sz="1050">
+                          <a:solidFill>
+                            <a:srgbClr val="3D3C38"/>
+                          </a:solidFill>
+                          <a:latin typeface="Arial"/>
+                        </a:rPr>
+                        <a:t>Inpatient charge skew</a:t>
+                      </a:r>
+                    </a:p>
+                  </a:txBody>
+                  <a:tcPr>
+                    <a:solidFill>
+                      <a:srgbClr val="FAF8F2"/>
+                    </a:solidFill>
+                  </a:tcPr>
+                </a:tc>
+                <a:tc>
+                  <a:txBody>
+                    <a:bodyPr/>
+                    <a:lstStyle/>
+                    <a:p>
+                      <a:r>
+                        <a:rPr sz="1050">
+                          <a:solidFill>
+                            <a:srgbClr val="3D3C38"/>
+                          </a:solidFill>
+                          <a:latin typeface="Arial"/>
+                        </a:rPr>
+                        <a:t>11.4</a:t>
+                      </a:r>
+                    </a:p>
+                  </a:txBody>
+                  <a:tcPr>
+                    <a:solidFill>
+                      <a:srgbClr val="FAF8F2"/>
+                    </a:solidFill>
+                  </a:tcPr>
+                </a:tc>
+                <a:tc>
+                  <a:txBody>
+                    <a:bodyPr/>
+                    <a:lstStyle/>
+                    <a:p>
+                      <a:r>
+                        <a:rPr sz="1050">
+                          <a:solidFill>
+                            <a:srgbClr val="3D3C38"/>
+                          </a:solidFill>
+                          <a:latin typeface="Arial"/>
+                        </a:rPr>
+                        <a:t>12.5</a:t>
+                      </a:r>
+                    </a:p>
+                  </a:txBody>
+                  <a:tcPr>
+                    <a:solidFill>
+                      <a:srgbClr val="FAF8F2"/>
+                    </a:solidFill>
+                  </a:tcPr>
+                </a:tc>
+              </a:tr>
+              <a:tr h="326571">
+                <a:tc>
+                  <a:txBody>
+                    <a:bodyPr/>
+                    <a:lstStyle/>
+                    <a:p>
+                      <a:r>
+                        <a:rPr sz="1050">
+                          <a:solidFill>
+                            <a:srgbClr val="3D3C38"/>
+                          </a:solidFill>
+                          <a:latin typeface="Arial"/>
+                        </a:rPr>
+                        <a:t>Within-DRG dispersion (p90/p10)</a:t>
+                      </a:r>
+                    </a:p>
+                  </a:txBody>
+                  <a:tcPr>
+                    <a:solidFill>
+                      <a:srgbClr val="EDE8E0"/>
+                    </a:solidFill>
+                  </a:tcPr>
+                </a:tc>
+                <a:tc>
+                  <a:txBody>
+                    <a:bodyPr/>
+                    <a:lstStyle/>
+                    <a:p>
+                      <a:r>
+                        <a:rPr sz="1050">
+                          <a:solidFill>
+                            <a:srgbClr val="3D3C38"/>
+                          </a:solidFill>
+                          <a:latin typeface="Arial"/>
+                        </a:rPr>
+                        <a:t>3.63×</a:t>
+                      </a:r>
+                    </a:p>
+                  </a:txBody>
+                  <a:tcPr>
+                    <a:solidFill>
+                      <a:srgbClr val="EDE8E0"/>
+                    </a:solidFill>
+                  </a:tcPr>
+                </a:tc>
+                <a:tc>
+                  <a:txBody>
+                    <a:bodyPr/>
+                    <a:lstStyle/>
+                    <a:p>
+                      <a:r>
+                        <a:rPr sz="1050">
+                          <a:solidFill>
+                            <a:srgbClr val="3D3C38"/>
+                          </a:solidFill>
+                          <a:latin typeface="Arial"/>
+                        </a:rPr>
+                        <a:t>3.67×</a:t>
+                      </a:r>
+                    </a:p>
+                  </a:txBody>
+                  <a:tcPr>
+                    <a:solidFill>
+                      <a:srgbClr val="EDE8E0"/>
+                    </a:solidFill>
+                  </a:tcPr>
+                </a:tc>
+              </a:tr>
+              <a:tr h="326571">
+                <a:tc>
+                  <a:txBody>
+                    <a:bodyPr/>
+                    <a:lstStyle/>
+                    <a:p>
+                      <a:r>
+                        <a:rPr sz="1050">
+                          <a:solidFill>
+                            <a:srgbClr val="3D3C38"/>
+                          </a:solidFill>
+                          <a:latin typeface="Arial"/>
+                        </a:rPr>
+                        <a:t>Median markup — IP / OP</a:t>
+                      </a:r>
+                    </a:p>
+                  </a:txBody>
+                  <a:tcPr>
+                    <a:solidFill>
+                      <a:srgbClr val="FAF8F2"/>
+                    </a:solidFill>
+                  </a:tcPr>
+                </a:tc>
+                <a:tc>
+                  <a:txBody>
+                    <a:bodyPr/>
+                    <a:lstStyle/>
+                    <a:p>
+                      <a:r>
+                        <a:rPr sz="1050">
+                          <a:solidFill>
+                            <a:srgbClr val="3D3C38"/>
+                          </a:solidFill>
+                          <a:latin typeface="Arial"/>
+                        </a:rPr>
+                        <a:t>5.37× / 7.38×</a:t>
+                      </a:r>
+                    </a:p>
+                  </a:txBody>
+                  <a:tcPr>
+                    <a:solidFill>
+                      <a:srgbClr val="FAF8F2"/>
+                    </a:solidFill>
+                  </a:tcPr>
+                </a:tc>
+                <a:tc>
+                  <a:txBody>
+                    <a:bodyPr/>
+                    <a:lstStyle/>
+                    <a:p>
+                      <a:r>
+                        <a:rPr sz="1050">
+                          <a:solidFill>
+                            <a:srgbClr val="3D3C38"/>
+                          </a:solidFill>
+                          <a:latin typeface="Arial"/>
+                        </a:rPr>
+                        <a:t>5.52× / 7.62×</a:t>
+                      </a:r>
+                    </a:p>
+                  </a:txBody>
+                  <a:tcPr>
+                    <a:solidFill>
+                      <a:srgbClr val="FAF8F2"/>
+                    </a:solidFill>
+                  </a:tcPr>
+                </a:tc>
+              </a:tr>
+              <a:tr h="326571">
+                <a:tc>
+                  <a:txBody>
+                    <a:bodyPr/>
+                    <a:lstStyle/>
+                    <a:p>
+                      <a:r>
+                        <a:rPr sz="1050">
+                          <a:solidFill>
+                            <a:srgbClr val="3D3C38"/>
+                          </a:solidFill>
+                          <a:latin typeface="Arial"/>
+                        </a:rPr>
+                        <a:t>Non-metro vs metro (case-mix adj.)</a:t>
+                      </a:r>
+                    </a:p>
+                  </a:txBody>
+                  <a:tcPr>
+                    <a:solidFill>
+                      <a:srgbClr val="EDE8E0"/>
+                    </a:solidFill>
+                  </a:tcPr>
+                </a:tc>
+                <a:tc>
+                  <a:txBody>
+                    <a:bodyPr/>
+                    <a:lstStyle/>
+                    <a:p>
+                      <a:r>
+                        <a:rPr sz="1050">
+                          <a:solidFill>
+                            <a:srgbClr val="3D3C38"/>
+                          </a:solidFill>
+                          <a:latin typeface="Arial"/>
+                        </a:rPr>
+                        <a:t>−27.6%</a:t>
+                      </a:r>
+                    </a:p>
+                  </a:txBody>
+                  <a:tcPr>
+                    <a:solidFill>
+                      <a:srgbClr val="EDE8E0"/>
+                    </a:solidFill>
+                  </a:tcPr>
+                </a:tc>
+                <a:tc>
+                  <a:txBody>
+                    <a:bodyPr/>
+                    <a:lstStyle/>
+                    <a:p>
+                      <a:r>
+                        <a:rPr sz="1050">
+                          <a:solidFill>
+                            <a:srgbClr val="3D3C38"/>
+                          </a:solidFill>
+                          <a:latin typeface="Arial"/>
+                        </a:rPr>
+                        <a:t>−26.6%</a:t>
+                      </a:r>
+                    </a:p>
+                  </a:txBody>
+                  <a:tcPr>
+                    <a:solidFill>
+                      <a:srgbClr val="EDE8E0"/>
+                    </a:solidFill>
+                  </a:tcPr>
+                </a:tc>
+              </a:tr>
+              <a:tr h="326571">
+                <a:tc>
+                  <a:txBody>
+                    <a:bodyPr/>
+                    <a:lstStyle/>
+                    <a:p>
+                      <a:r>
+                        <a:rPr sz="1050">
+                          <a:solidFill>
+                            <a:srgbClr val="3D3C38"/>
+                          </a:solidFill>
+                          <a:latin typeface="Arial"/>
+                        </a:rPr>
+                        <a:t>IP↔OP pricing-culture (Spearman)</a:t>
+                      </a:r>
+                    </a:p>
+                  </a:txBody>
+                  <a:tcPr>
+                    <a:solidFill>
+                      <a:srgbClr val="FAF8F2"/>
+                    </a:solidFill>
+                  </a:tcPr>
+                </a:tc>
+                <a:tc>
+                  <a:txBody>
+                    <a:bodyPr/>
+                    <a:lstStyle/>
+                    <a:p>
+                      <a:r>
+                        <a:rPr sz="1050">
+                          <a:solidFill>
+                            <a:srgbClr val="3D3C38"/>
+                          </a:solidFill>
+                          <a:latin typeface="Arial"/>
+                        </a:rPr>
+                        <a:t>0.83</a:t>
+                      </a:r>
+                    </a:p>
+                  </a:txBody>
+                  <a:tcPr>
+                    <a:solidFill>
+                      <a:srgbClr val="FAF8F2"/>
+                    </a:solidFill>
+                  </a:tcPr>
+                </a:tc>
+                <a:tc>
+                  <a:txBody>
+                    <a:bodyPr/>
+                    <a:lstStyle/>
+                    <a:p>
+                      <a:r>
+                        <a:rPr sz="1050">
+                          <a:solidFill>
+                            <a:srgbClr val="3D3C38"/>
+                          </a:solidFill>
+                          <a:latin typeface="Arial"/>
+                        </a:rPr>
+                        <a:t>0.82</a:t>
+                      </a:r>
+                    </a:p>
+                  </a:txBody>
+                  <a:tcPr>
+                    <a:solidFill>
+                      <a:srgbClr val="FAF8F2"/>
+                    </a:solidFill>
+                  </a:tcPr>
+                </a:tc>
+              </a:tr>
+              <a:tr h="326574">
+                <a:tc>
+                  <a:txBody>
+                    <a:bodyPr/>
+                    <a:lstStyle/>
+                    <a:p>
+                      <a:r>
+                        <a:rPr sz="1050">
+                          <a:solidFill>
+                            <a:srgbClr val="3D3C38"/>
+                          </a:solidFill>
+                          <a:latin typeface="Arial"/>
+                        </a:rPr>
+                        <a:t>For-profit charge premium (median)</a:t>
+                      </a:r>
+                    </a:p>
+                  </a:txBody>
+                  <a:tcPr>
+                    <a:solidFill>
+                      <a:srgbClr val="EDE8E0"/>
+                    </a:solidFill>
+                  </a:tcPr>
+                </a:tc>
+                <a:tc>
+                  <a:txBody>
+                    <a:bodyPr/>
+                    <a:lstStyle/>
+                    <a:p>
+                      <a:r>
+                        <a:rPr sz="1050">
+                          <a:solidFill>
+                            <a:srgbClr val="3D3C38"/>
+                          </a:solidFill>
+                          <a:latin typeface="Arial"/>
+                        </a:rPr>
+                        <a:t>+43%</a:t>
+                      </a:r>
+                    </a:p>
+                  </a:txBody>
+                  <a:tcPr>
+                    <a:solidFill>
+                      <a:srgbClr val="EDE8E0"/>
+                    </a:solidFill>
+                  </a:tcPr>
+                </a:tc>
+                <a:tc>
+                  <a:txBody>
+                    <a:bodyPr/>
+                    <a:lstStyle/>
+                    <a:p>
+                      <a:r>
+                        <a:rPr sz="1050">
+                          <a:solidFill>
+                            <a:srgbClr val="3D3C38"/>
+                          </a:solidFill>
+                          <a:latin typeface="Arial"/>
+                        </a:rPr>
+                        <a:t>+49%</a:t>
+                      </a:r>
+                    </a:p>
+                  </a:txBody>
+                  <a:tcPr>
+                    <a:solidFill>
+                      <a:srgbClr val="EDE8E0"/>
+                    </a:solidFill>
+                  </a:tcPr>
+                </a:tc>
+              </a:tr>
+            </a:tbl>
+          </a:graphicData>
+        </a:graphic>
+      </p:graphicFrame>
+      <p:sp>
+        <p:nvSpPr>
+          <p:cNvPr id="6" name="TextBox 5"/>
+          <p:cNvSpPr txBox="1"/>
+          <p:nvPr/>
+        </p:nvSpPr>
+        <p:spPr>
+          <a:xfrm>
+            <a:off x="548640" y="4297680"/>
+            <a:ext cx="11155680" cy="4297680"/>
+          </a:xfrm>
+          <a:prstGeom prst="rect">
+            <a:avLst/>
+          </a:prstGeom>
+          <a:noFill/>
+        </p:spPr>
+        <p:txBody>
+          <a:bodyPr wrap="square">
+            <a:spAutoFit/>
+          </a:bodyPr>
+          <a:lstStyle/>
+          <a:p>
+            <a:pPr>
+              <a:spcAft>
+                <a:spcPts val="1000"/>
+              </a:spcAft>
+            </a:pPr>
+            <a:r>
+              <a:rPr sz="1100">
+                <a:solidFill>
+                  <a:srgbClr val="FF612B"/>
+                </a:solidFill>
+                <a:latin typeface="Arial"/>
+              </a:rPr>
+              <a:t>■  </a:t>
+            </a:r>
+            <a:r>
+              <a:rPr sz="1200" b="1">
+                <a:solidFill>
+                  <a:srgbClr val="3D3C38"/>
+                </a:solidFill>
+                <a:latin typeface="Arial"/>
+              </a:rPr>
+              <a:t>Limits: </a:t>
+            </a:r>
+            <a:r>
+              <a:rPr sz="1200" b="0">
+                <a:solidFill>
+                  <a:srgbClr val="3D3C38"/>
+                </a:solidFill>
+                <a:latin typeface="Arial"/>
+              </a:rPr>
+              <a:t>submitted charges, not negotiated commercial rates; Medicare data (commercial-to-Medicare ratios vary); 2013 ZIP vintage (93.6% geocoded); chain detection undercounts HCA (the effect is a lower bound); all effects associational (causal design framed, not run).</a:t>
             </a:r>
           </a:p>
         </p:txBody>
@@ -7216,13 +10562,22 @@
               <a:t>■  </a:t>
             </a:r>
             <a:r>
+              <a:rPr sz="1500" b="1">
+                <a:solidFill>
+                  <a:srgbClr val="3D3C38"/>
+                </a:solidFill>
+                <a:latin typeface="Arial"/>
+              </a:rPr>
+              <a:t>▶ Live demo — switch to the dashboard: </a:t>
+            </a:r>
+            <a:r>
               <a:rPr sz="1500" b="0">
                 <a:solidFill>
                   <a:srgbClr val="3D3C38"/>
                 </a:solidFill>
                 <a:latin typeface="Arial"/>
               </a:rPr>
-              <a:t>In the live dashboard you can pick a hospital type and see the flagged ones.</a:t>
+              <a:t>pick a hospital type; toggle the ✕ avoidances on/off.</a:t>
             </a:r>
           </a:p>
         </p:txBody>

</xml_diff>